<commit_message>
docs: rehacer el diagrama de arquitectura y actualizar informe y presentacion
- El diagrama de arquitectura dejaba una franja vacia bajo el panel de
  herramientas; se reorganiza para ocupar todo el lienzo.
- Diagrama To Be: la etiqueta "git push" quedaba lejos de las flechas.
- Informe Word regenerado con los diagramas corregidos e indice actualizado.
- Presentacion con ajustes de separacion y equilibrio en 5, 9, 13, 14 y 16.
</commit_message>
<xml_diff>
--- a/docs/Avance1-BiblioTech-UTP.pptx
+++ b/docs/Avance1-BiblioTech-UTP.pptx
@@ -6618,7 +6618,7 @@
         </p:nvSpPr>
         <p:spPr>
           <a:xfrm>
-            <a:off x="640080" y="2048256"/>
+            <a:off x="640080" y="2194560"/>
             <a:ext cx="402336" cy="402336"/>
           </a:xfrm>
           <a:prstGeom prst="ellipse">
@@ -6638,7 +6638,7 @@
         </p:nvSpPr>
         <p:spPr>
           <a:xfrm>
-            <a:off x="640080" y="2048256"/>
+            <a:off x="640080" y="2194560"/>
             <a:ext cx="402336" cy="402336"/>
           </a:xfrm>
           <a:prstGeom prst="rect">
@@ -6677,7 +6677,7 @@
         </p:nvSpPr>
         <p:spPr>
           <a:xfrm>
-            <a:off x="1225296" y="2048256"/>
+            <a:off x="1225296" y="2194560"/>
             <a:ext cx="4718304" cy="402336"/>
           </a:xfrm>
           <a:prstGeom prst="rect">
@@ -6716,7 +6716,7 @@
         </p:nvSpPr>
         <p:spPr>
           <a:xfrm>
-            <a:off x="640080" y="2706624"/>
+            <a:off x="640080" y="2999232"/>
             <a:ext cx="402336" cy="402336"/>
           </a:xfrm>
           <a:prstGeom prst="ellipse">
@@ -6736,7 +6736,7 @@
         </p:nvSpPr>
         <p:spPr>
           <a:xfrm>
-            <a:off x="640080" y="2706624"/>
+            <a:off x="640080" y="2999232"/>
             <a:ext cx="402336" cy="402336"/>
           </a:xfrm>
           <a:prstGeom prst="rect">
@@ -6775,7 +6775,7 @@
         </p:nvSpPr>
         <p:spPr>
           <a:xfrm>
-            <a:off x="1225296" y="2706624"/>
+            <a:off x="1225296" y="2999232"/>
             <a:ext cx="4718304" cy="402336"/>
           </a:xfrm>
           <a:prstGeom prst="rect">
@@ -6814,7 +6814,7 @@
         </p:nvSpPr>
         <p:spPr>
           <a:xfrm>
-            <a:off x="640080" y="3364992"/>
+            <a:off x="640080" y="3803904"/>
             <a:ext cx="402336" cy="402336"/>
           </a:xfrm>
           <a:prstGeom prst="ellipse">
@@ -6834,7 +6834,7 @@
         </p:nvSpPr>
         <p:spPr>
           <a:xfrm>
-            <a:off x="640080" y="3364992"/>
+            <a:off x="640080" y="3803904"/>
             <a:ext cx="402336" cy="402336"/>
           </a:xfrm>
           <a:prstGeom prst="rect">
@@ -6873,7 +6873,7 @@
         </p:nvSpPr>
         <p:spPr>
           <a:xfrm>
-            <a:off x="1225296" y="3364992"/>
+            <a:off x="1225296" y="3803904"/>
             <a:ext cx="4718304" cy="402336"/>
           </a:xfrm>
           <a:prstGeom prst="rect">
@@ -6912,7 +6912,7 @@
         </p:nvSpPr>
         <p:spPr>
           <a:xfrm>
-            <a:off x="640080" y="4023360"/>
+            <a:off x="640080" y="4608576"/>
             <a:ext cx="402336" cy="402336"/>
           </a:xfrm>
           <a:prstGeom prst="ellipse">
@@ -6932,7 +6932,7 @@
         </p:nvSpPr>
         <p:spPr>
           <a:xfrm>
-            <a:off x="640080" y="4023360"/>
+            <a:off x="640080" y="4608576"/>
             <a:ext cx="402336" cy="402336"/>
           </a:xfrm>
           <a:prstGeom prst="rect">
@@ -6971,7 +6971,7 @@
         </p:nvSpPr>
         <p:spPr>
           <a:xfrm>
-            <a:off x="1225296" y="4023360"/>
+            <a:off x="1225296" y="4608576"/>
             <a:ext cx="4718304" cy="402336"/>
           </a:xfrm>
           <a:prstGeom prst="rect">
@@ -7010,7 +7010,7 @@
         </p:nvSpPr>
         <p:spPr>
           <a:xfrm>
-            <a:off x="640080" y="4681728"/>
+            <a:off x="640080" y="5413248"/>
             <a:ext cx="402336" cy="402336"/>
           </a:xfrm>
           <a:prstGeom prst="ellipse">
@@ -7030,7 +7030,7 @@
         </p:nvSpPr>
         <p:spPr>
           <a:xfrm>
-            <a:off x="640080" y="4681728"/>
+            <a:off x="640080" y="5413248"/>
             <a:ext cx="402336" cy="402336"/>
           </a:xfrm>
           <a:prstGeom prst="rect">
@@ -7069,7 +7069,7 @@
         </p:nvSpPr>
         <p:spPr>
           <a:xfrm>
-            <a:off x="1225296" y="4681728"/>
+            <a:off x="1225296" y="5413248"/>
             <a:ext cx="4718304" cy="402336"/>
           </a:xfrm>
           <a:prstGeom prst="rect">
@@ -8901,7 +8901,7 @@
               <a:buNone/>
             </a:pPr>
             <a:r>
-              <a:rPr lang="en-US" sz="1150" dirty="0">
+              <a:rPr lang="en-US" sz="1250" dirty="0">
                 <a:solidFill>
                   <a:srgbClr val="55606E"/>
                 </a:solidFill>
@@ -8911,20 +8911,20 @@
               </a:rPr>
               <a:t>Un integrante había publicado directamente en main un rediseño completo de la interfaz: 16 archivos y 1 313 líneas nuevas.</a:t>
             </a:r>
-            <a:endParaRPr lang="en-US" sz="1150" dirty="0"/>
-          </a:p>
-          <a:p>
-            <a:pPr indent="0" marL="0">
-              <a:buNone/>
-            </a:pPr>
-            <a:endParaRPr lang="en-US" sz="1150" dirty="0"/>
-          </a:p>
-          <a:p>
-            <a:pPr indent="0" marL="0">
-              <a:buNone/>
-            </a:pPr>
-            <a:r>
-              <a:rPr lang="en-US" sz="1150" dirty="0">
+            <a:endParaRPr lang="en-US" sz="1250" dirty="0"/>
+          </a:p>
+          <a:p>
+            <a:pPr indent="0" marL="0">
+              <a:buNone/>
+            </a:pPr>
+            <a:endParaRPr lang="en-US" sz="1250" dirty="0"/>
+          </a:p>
+          <a:p>
+            <a:pPr indent="0" marL="0">
+              <a:buNone/>
+            </a:pPr>
+            <a:r>
+              <a:rPr lang="en-US" sz="1250" dirty="0">
                 <a:solidFill>
                   <a:srgbClr val="55606E"/>
                 </a:solidFill>
@@ -8934,20 +8934,20 @@
               </a:rPr>
               <a:t>Forzarlo lo habría borrado todo. Hacer fetch, revisar qué llegó y fusionar tomó dos minutos y no costó una sola línea de código.</a:t>
             </a:r>
-            <a:endParaRPr lang="en-US" sz="1150" dirty="0"/>
-          </a:p>
-          <a:p>
-            <a:pPr indent="0" marL="0">
-              <a:buNone/>
-            </a:pPr>
-            <a:endParaRPr lang="en-US" sz="1150" dirty="0"/>
-          </a:p>
-          <a:p>
-            <a:pPr indent="0" marL="0">
-              <a:buNone/>
-            </a:pPr>
-            <a:r>
-              <a:rPr lang="en-US" sz="1150" dirty="0">
+            <a:endParaRPr lang="en-US" sz="1250" dirty="0"/>
+          </a:p>
+          <a:p>
+            <a:pPr indent="0" marL="0">
+              <a:buNone/>
+            </a:pPr>
+            <a:endParaRPr lang="en-US" sz="1250" dirty="0"/>
+          </a:p>
+          <a:p>
+            <a:pPr indent="0" marL="0">
+              <a:buNone/>
+            </a:pPr>
+            <a:r>
+              <a:rPr lang="en-US" sz="1250" dirty="0">
                 <a:solidFill>
                   <a:srgbClr val="55606E"/>
                 </a:solidFill>
@@ -8957,7 +8957,7 @@
               </a:rPr>
               <a:t>El push rechazado no estorba: protege.</a:t>
             </a:r>
-            <a:endParaRPr lang="en-US" sz="1150" dirty="0"/>
+            <a:endParaRPr lang="en-US" sz="1250" dirty="0"/>
           </a:p>
         </p:txBody>
       </p:sp>
@@ -10171,8 +10171,8 @@
         </p:nvSpPr>
         <p:spPr>
           <a:xfrm>
-            <a:off x="640080" y="1755648"/>
-            <a:ext cx="5303520" cy="896112"/>
+            <a:off x="640080" y="1719072"/>
+            <a:ext cx="5303520" cy="877824"/>
           </a:xfrm>
           <a:prstGeom prst="rect">
             <a:avLst/>
@@ -10196,8 +10196,8 @@
         </p:nvSpPr>
         <p:spPr>
           <a:xfrm>
-            <a:off x="640080" y="1755648"/>
-            <a:ext cx="68580" cy="896112"/>
+            <a:off x="640080" y="1719072"/>
+            <a:ext cx="68580" cy="877824"/>
           </a:xfrm>
           <a:prstGeom prst="rect">
             <a:avLst/>
@@ -10216,7 +10216,7 @@
         </p:nvSpPr>
         <p:spPr>
           <a:xfrm>
-            <a:off x="841248" y="1874520"/>
+            <a:off x="841248" y="1837944"/>
             <a:ext cx="4901184" cy="274320"/>
           </a:xfrm>
           <a:prstGeom prst="rect">
@@ -10255,8 +10255,8 @@
         </p:nvSpPr>
         <p:spPr>
           <a:xfrm>
-            <a:off x="841248" y="2167128"/>
-            <a:ext cx="4901184" cy="365760"/>
+            <a:off x="841248" y="2130552"/>
+            <a:ext cx="4901184" cy="347472"/>
           </a:xfrm>
           <a:prstGeom prst="rect">
             <a:avLst/>
@@ -10294,8 +10294,8 @@
         </p:nvSpPr>
         <p:spPr>
           <a:xfrm>
-            <a:off x="640080" y="2907792"/>
-            <a:ext cx="5303520" cy="896112"/>
+            <a:off x="640080" y="2889504"/>
+            <a:ext cx="5303520" cy="877824"/>
           </a:xfrm>
           <a:prstGeom prst="rect">
             <a:avLst/>
@@ -10319,8 +10319,8 @@
         </p:nvSpPr>
         <p:spPr>
           <a:xfrm>
-            <a:off x="640080" y="2907792"/>
-            <a:ext cx="68580" cy="896112"/>
+            <a:off x="640080" y="2889504"/>
+            <a:ext cx="68580" cy="877824"/>
           </a:xfrm>
           <a:prstGeom prst="rect">
             <a:avLst/>
@@ -10339,7 +10339,7 @@
         </p:nvSpPr>
         <p:spPr>
           <a:xfrm>
-            <a:off x="841248" y="3026664"/>
+            <a:off x="841248" y="3008376"/>
             <a:ext cx="4901184" cy="274320"/>
           </a:xfrm>
           <a:prstGeom prst="rect">
@@ -10378,8 +10378,8 @@
         </p:nvSpPr>
         <p:spPr>
           <a:xfrm>
-            <a:off x="841248" y="3319272"/>
-            <a:ext cx="4901184" cy="365760"/>
+            <a:off x="841248" y="3300984"/>
+            <a:ext cx="4901184" cy="347472"/>
           </a:xfrm>
           <a:prstGeom prst="rect">
             <a:avLst/>
@@ -10418,7 +10418,7 @@
         <p:spPr>
           <a:xfrm>
             <a:off x="640080" y="4059936"/>
-            <a:ext cx="5303520" cy="896112"/>
+            <a:ext cx="5303520" cy="877824"/>
           </a:xfrm>
           <a:prstGeom prst="rect">
             <a:avLst/>
@@ -10443,7 +10443,7 @@
         <p:spPr>
           <a:xfrm>
             <a:off x="640080" y="4059936"/>
-            <a:ext cx="68580" cy="896112"/>
+            <a:ext cx="68580" cy="877824"/>
           </a:xfrm>
           <a:prstGeom prst="rect">
             <a:avLst/>
@@ -10502,7 +10502,7 @@
         <p:spPr>
           <a:xfrm>
             <a:off x="841248" y="4471416"/>
-            <a:ext cx="4901184" cy="365760"/>
+            <a:ext cx="4901184" cy="347472"/>
           </a:xfrm>
           <a:prstGeom prst="rect">
             <a:avLst/>
@@ -10540,8 +10540,8 @@
         </p:nvSpPr>
         <p:spPr>
           <a:xfrm>
-            <a:off x="640080" y="5212080"/>
-            <a:ext cx="5303520" cy="896112"/>
+            <a:off x="640080" y="5230368"/>
+            <a:ext cx="5303520" cy="877824"/>
           </a:xfrm>
           <a:prstGeom prst="rect">
             <a:avLst/>
@@ -10565,8 +10565,8 @@
         </p:nvSpPr>
         <p:spPr>
           <a:xfrm>
-            <a:off x="640080" y="5212080"/>
-            <a:ext cx="68580" cy="896112"/>
+            <a:off x="640080" y="5230368"/>
+            <a:ext cx="68580" cy="877824"/>
           </a:xfrm>
           <a:prstGeom prst="rect">
             <a:avLst/>
@@ -10585,7 +10585,7 @@
         </p:nvSpPr>
         <p:spPr>
           <a:xfrm>
-            <a:off x="841248" y="5330952"/>
+            <a:off x="841248" y="5349240"/>
             <a:ext cx="4901184" cy="274320"/>
           </a:xfrm>
           <a:prstGeom prst="rect">
@@ -10624,8 +10624,8 @@
         </p:nvSpPr>
         <p:spPr>
           <a:xfrm>
-            <a:off x="841248" y="5623560"/>
-            <a:ext cx="4901184" cy="365760"/>
+            <a:off x="841248" y="5641848"/>
+            <a:ext cx="4901184" cy="347472"/>
           </a:xfrm>
           <a:prstGeom prst="rect">
             <a:avLst/>
@@ -10663,8 +10663,8 @@
         </p:nvSpPr>
         <p:spPr>
           <a:xfrm>
-            <a:off x="6217920" y="1755648"/>
-            <a:ext cx="5303520" cy="896112"/>
+            <a:off x="6217920" y="1719072"/>
+            <a:ext cx="5303520" cy="877824"/>
           </a:xfrm>
           <a:prstGeom prst="rect">
             <a:avLst/>
@@ -10688,8 +10688,8 @@
         </p:nvSpPr>
         <p:spPr>
           <a:xfrm>
-            <a:off x="6217920" y="1755648"/>
-            <a:ext cx="68580" cy="896112"/>
+            <a:off x="6217920" y="1719072"/>
+            <a:ext cx="68580" cy="877824"/>
           </a:xfrm>
           <a:prstGeom prst="rect">
             <a:avLst/>
@@ -10708,7 +10708,7 @@
         </p:nvSpPr>
         <p:spPr>
           <a:xfrm>
-            <a:off x="6419088" y="1874520"/>
+            <a:off x="6419088" y="1837944"/>
             <a:ext cx="4901184" cy="274320"/>
           </a:xfrm>
           <a:prstGeom prst="rect">
@@ -10747,8 +10747,8 @@
         </p:nvSpPr>
         <p:spPr>
           <a:xfrm>
-            <a:off x="6419088" y="2167128"/>
-            <a:ext cx="4901184" cy="365760"/>
+            <a:off x="6419088" y="2130552"/>
+            <a:ext cx="4901184" cy="347472"/>
           </a:xfrm>
           <a:prstGeom prst="rect">
             <a:avLst/>
@@ -10786,8 +10786,8 @@
         </p:nvSpPr>
         <p:spPr>
           <a:xfrm>
-            <a:off x="6217920" y="2907792"/>
-            <a:ext cx="5303520" cy="896112"/>
+            <a:off x="6217920" y="2889504"/>
+            <a:ext cx="5303520" cy="877824"/>
           </a:xfrm>
           <a:prstGeom prst="rect">
             <a:avLst/>
@@ -10811,8 +10811,8 @@
         </p:nvSpPr>
         <p:spPr>
           <a:xfrm>
-            <a:off x="6217920" y="2907792"/>
-            <a:ext cx="68580" cy="896112"/>
+            <a:off x="6217920" y="2889504"/>
+            <a:ext cx="68580" cy="877824"/>
           </a:xfrm>
           <a:prstGeom prst="rect">
             <a:avLst/>
@@ -10831,7 +10831,7 @@
         </p:nvSpPr>
         <p:spPr>
           <a:xfrm>
-            <a:off x="6419088" y="3026664"/>
+            <a:off x="6419088" y="3008376"/>
             <a:ext cx="4901184" cy="274320"/>
           </a:xfrm>
           <a:prstGeom prst="rect">
@@ -10870,8 +10870,8 @@
         </p:nvSpPr>
         <p:spPr>
           <a:xfrm>
-            <a:off x="6419088" y="3319272"/>
-            <a:ext cx="4901184" cy="365760"/>
+            <a:off x="6419088" y="3300984"/>
+            <a:ext cx="4901184" cy="347472"/>
           </a:xfrm>
           <a:prstGeom prst="rect">
             <a:avLst/>
@@ -10910,7 +10910,7 @@
         <p:spPr>
           <a:xfrm>
             <a:off x="6217920" y="4059936"/>
-            <a:ext cx="5303520" cy="896112"/>
+            <a:ext cx="5303520" cy="877824"/>
           </a:xfrm>
           <a:prstGeom prst="rect">
             <a:avLst/>
@@ -10935,7 +10935,7 @@
         <p:spPr>
           <a:xfrm>
             <a:off x="6217920" y="4059936"/>
-            <a:ext cx="68580" cy="896112"/>
+            <a:ext cx="68580" cy="877824"/>
           </a:xfrm>
           <a:prstGeom prst="rect">
             <a:avLst/>
@@ -10994,7 +10994,7 @@
         <p:spPr>
           <a:xfrm>
             <a:off x="6419088" y="4471416"/>
-            <a:ext cx="4901184" cy="365760"/>
+            <a:ext cx="4901184" cy="347472"/>
           </a:xfrm>
           <a:prstGeom prst="rect">
             <a:avLst/>
@@ -11032,8 +11032,8 @@
         </p:nvSpPr>
         <p:spPr>
           <a:xfrm>
-            <a:off x="6217920" y="5212080"/>
-            <a:ext cx="5303520" cy="896112"/>
+            <a:off x="6217920" y="5230368"/>
+            <a:ext cx="5303520" cy="877824"/>
           </a:xfrm>
           <a:prstGeom prst="rect">
             <a:avLst/>
@@ -11057,8 +11057,8 @@
         </p:nvSpPr>
         <p:spPr>
           <a:xfrm>
-            <a:off x="6217920" y="5212080"/>
-            <a:ext cx="68580" cy="896112"/>
+            <a:off x="6217920" y="5230368"/>
+            <a:ext cx="68580" cy="877824"/>
           </a:xfrm>
           <a:prstGeom prst="rect">
             <a:avLst/>
@@ -11077,7 +11077,7 @@
         </p:nvSpPr>
         <p:spPr>
           <a:xfrm>
-            <a:off x="6419088" y="5330952"/>
+            <a:off x="6419088" y="5349240"/>
             <a:ext cx="4901184" cy="274320"/>
           </a:xfrm>
           <a:prstGeom prst="rect">
@@ -11116,8 +11116,8 @@
         </p:nvSpPr>
         <p:spPr>
           <a:xfrm>
-            <a:off x="6419088" y="5623560"/>
-            <a:ext cx="4901184" cy="365760"/>
+            <a:off x="6419088" y="5641848"/>
+            <a:ext cx="4901184" cy="347472"/>
           </a:xfrm>
           <a:prstGeom prst="rect">
             <a:avLst/>
@@ -14884,7 +14884,7 @@
         </p:nvSpPr>
         <p:spPr>
           <a:xfrm>
-            <a:off x="640080" y="2560320"/>
+            <a:off x="640080" y="2596896"/>
             <a:ext cx="5303520" cy="914400"/>
           </a:xfrm>
           <a:prstGeom prst="rect">
@@ -14916,7 +14916,7 @@
         </p:nvSpPr>
         <p:spPr>
           <a:xfrm>
-            <a:off x="640080" y="2560320"/>
+            <a:off x="640080" y="2596896"/>
             <a:ext cx="68580" cy="914400"/>
           </a:xfrm>
           <a:prstGeom prst="rect">
@@ -14936,7 +14936,7 @@
         </p:nvSpPr>
         <p:spPr>
           <a:xfrm>
-            <a:off x="841248" y="2679192"/>
+            <a:off x="841248" y="2715768"/>
             <a:ext cx="4901184" cy="274320"/>
           </a:xfrm>
           <a:prstGeom prst="rect">
@@ -14975,7 +14975,7 @@
         </p:nvSpPr>
         <p:spPr>
           <a:xfrm>
-            <a:off x="841248" y="2971800"/>
+            <a:off x="841248" y="3008376"/>
             <a:ext cx="4901184" cy="384048"/>
           </a:xfrm>
           <a:prstGeom prst="rect">
@@ -15014,7 +15014,7 @@
         </p:nvSpPr>
         <p:spPr>
           <a:xfrm>
-            <a:off x="640080" y="3730752"/>
+            <a:off x="640080" y="3803904"/>
             <a:ext cx="5303520" cy="914400"/>
           </a:xfrm>
           <a:prstGeom prst="rect">
@@ -15046,7 +15046,7 @@
         </p:nvSpPr>
         <p:spPr>
           <a:xfrm>
-            <a:off x="640080" y="3730752"/>
+            <a:off x="640080" y="3803904"/>
             <a:ext cx="68580" cy="914400"/>
           </a:xfrm>
           <a:prstGeom prst="rect">
@@ -15066,7 +15066,7 @@
         </p:nvSpPr>
         <p:spPr>
           <a:xfrm>
-            <a:off x="841248" y="3849624"/>
+            <a:off x="841248" y="3922776"/>
             <a:ext cx="4901184" cy="274320"/>
           </a:xfrm>
           <a:prstGeom prst="rect">
@@ -15105,7 +15105,7 @@
         </p:nvSpPr>
         <p:spPr>
           <a:xfrm>
-            <a:off x="841248" y="4142232"/>
+            <a:off x="841248" y="4215384"/>
             <a:ext cx="4901184" cy="384048"/>
           </a:xfrm>
           <a:prstGeom prst="rect">
@@ -15144,7 +15144,7 @@
         </p:nvSpPr>
         <p:spPr>
           <a:xfrm>
-            <a:off x="640080" y="4901184"/>
+            <a:off x="640080" y="5010912"/>
             <a:ext cx="5303520" cy="914400"/>
           </a:xfrm>
           <a:prstGeom prst="rect">
@@ -15176,7 +15176,7 @@
         </p:nvSpPr>
         <p:spPr>
           <a:xfrm>
-            <a:off x="640080" y="4901184"/>
+            <a:off x="640080" y="5010912"/>
             <a:ext cx="68580" cy="914400"/>
           </a:xfrm>
           <a:prstGeom prst="rect">
@@ -15196,7 +15196,7 @@
         </p:nvSpPr>
         <p:spPr>
           <a:xfrm>
-            <a:off x="841248" y="5020056"/>
+            <a:off x="841248" y="5129784"/>
             <a:ext cx="4901184" cy="274320"/>
           </a:xfrm>
           <a:prstGeom prst="rect">
@@ -15235,7 +15235,7 @@
         </p:nvSpPr>
         <p:spPr>
           <a:xfrm>
-            <a:off x="841248" y="5312664"/>
+            <a:off x="841248" y="5422392"/>
             <a:ext cx="4901184" cy="384048"/>
           </a:xfrm>
           <a:prstGeom prst="rect">
@@ -18632,8 +18632,8 @@
         </p:nvSpPr>
         <p:spPr>
           <a:xfrm>
-            <a:off x="640080" y="1353312"/>
-            <a:ext cx="2514600" cy="530352"/>
+            <a:off x="1851660" y="1353312"/>
+            <a:ext cx="1908810" cy="530352"/>
           </a:xfrm>
           <a:prstGeom prst="rect">
             <a:avLst/>
@@ -18657,7 +18657,7 @@
         </p:nvSpPr>
         <p:spPr>
           <a:xfrm>
-            <a:off x="640080" y="1353312"/>
+            <a:off x="1851660" y="1353312"/>
             <a:ext cx="50292" cy="530352"/>
           </a:xfrm>
           <a:prstGeom prst="rect">
@@ -18677,8 +18677,8 @@
         </p:nvSpPr>
         <p:spPr>
           <a:xfrm>
-            <a:off x="804672" y="1389888"/>
-            <a:ext cx="2286000" cy="237744"/>
+            <a:off x="1997964" y="1389888"/>
+            <a:ext cx="1737360" cy="237744"/>
           </a:xfrm>
           <a:prstGeom prst="rect">
             <a:avLst/>
@@ -18716,8 +18716,8 @@
         </p:nvSpPr>
         <p:spPr>
           <a:xfrm>
-            <a:off x="804672" y="1627632"/>
-            <a:ext cx="2286000" cy="237744"/>
+            <a:off x="1997964" y="1627632"/>
+            <a:ext cx="1737360" cy="237744"/>
           </a:xfrm>
           <a:prstGeom prst="rect">
             <a:avLst/>
@@ -18755,8 +18755,8 @@
         </p:nvSpPr>
         <p:spPr>
           <a:xfrm>
-            <a:off x="3429000" y="1353312"/>
-            <a:ext cx="2514600" cy="530352"/>
+            <a:off x="4034790" y="1353312"/>
+            <a:ext cx="1908810" cy="530352"/>
           </a:xfrm>
           <a:prstGeom prst="rect">
             <a:avLst/>
@@ -18780,7 +18780,7 @@
         </p:nvSpPr>
         <p:spPr>
           <a:xfrm>
-            <a:off x="3429000" y="1353312"/>
+            <a:off x="4034790" y="1353312"/>
             <a:ext cx="50292" cy="530352"/>
           </a:xfrm>
           <a:prstGeom prst="rect">
@@ -18800,8 +18800,8 @@
         </p:nvSpPr>
         <p:spPr>
           <a:xfrm>
-            <a:off x="3593592" y="1389888"/>
-            <a:ext cx="2286000" cy="237744"/>
+            <a:off x="4181094" y="1389888"/>
+            <a:ext cx="1737360" cy="237744"/>
           </a:xfrm>
           <a:prstGeom prst="rect">
             <a:avLst/>
@@ -18839,8 +18839,8 @@
         </p:nvSpPr>
         <p:spPr>
           <a:xfrm>
-            <a:off x="3593592" y="1627632"/>
-            <a:ext cx="2286000" cy="237744"/>
+            <a:off x="4181094" y="1627632"/>
+            <a:ext cx="1737360" cy="237744"/>
           </a:xfrm>
           <a:prstGeom prst="rect">
             <a:avLst/>
@@ -18879,7 +18879,7 @@
         <p:spPr>
           <a:xfrm>
             <a:off x="6217920" y="1353312"/>
-            <a:ext cx="2514600" cy="530352"/>
+            <a:ext cx="1908810" cy="530352"/>
           </a:xfrm>
           <a:prstGeom prst="rect">
             <a:avLst/>
@@ -18923,8 +18923,8 @@
         </p:nvSpPr>
         <p:spPr>
           <a:xfrm>
-            <a:off x="6382512" y="1389888"/>
-            <a:ext cx="2286000" cy="237744"/>
+            <a:off x="6364224" y="1389888"/>
+            <a:ext cx="1737360" cy="237744"/>
           </a:xfrm>
           <a:prstGeom prst="rect">
             <a:avLst/>
@@ -18962,8 +18962,8 @@
         </p:nvSpPr>
         <p:spPr>
           <a:xfrm>
-            <a:off x="6382512" y="1627632"/>
-            <a:ext cx="2286000" cy="237744"/>
+            <a:off x="6364224" y="1627632"/>
+            <a:ext cx="1737360" cy="237744"/>
           </a:xfrm>
           <a:prstGeom prst="rect">
             <a:avLst/>
@@ -19001,8 +19001,8 @@
         </p:nvSpPr>
         <p:spPr>
           <a:xfrm>
-            <a:off x="9006840" y="1353312"/>
-            <a:ext cx="2514600" cy="530352"/>
+            <a:off x="8401050" y="1353312"/>
+            <a:ext cx="1908810" cy="530352"/>
           </a:xfrm>
           <a:prstGeom prst="rect">
             <a:avLst/>
@@ -19026,7 +19026,7 @@
         </p:nvSpPr>
         <p:spPr>
           <a:xfrm>
-            <a:off x="9006840" y="1353312"/>
+            <a:off x="8401050" y="1353312"/>
             <a:ext cx="50292" cy="530352"/>
           </a:xfrm>
           <a:prstGeom prst="rect">
@@ -19046,8 +19046,8 @@
         </p:nvSpPr>
         <p:spPr>
           <a:xfrm>
-            <a:off x="9171432" y="1389888"/>
-            <a:ext cx="2286000" cy="237744"/>
+            <a:off x="8547354" y="1389888"/>
+            <a:ext cx="1737360" cy="237744"/>
           </a:xfrm>
           <a:prstGeom prst="rect">
             <a:avLst/>
@@ -19085,8 +19085,8 @@
         </p:nvSpPr>
         <p:spPr>
           <a:xfrm>
-            <a:off x="9171432" y="1627632"/>
-            <a:ext cx="2286000" cy="237744"/>
+            <a:off x="8547354" y="1627632"/>
+            <a:ext cx="1737360" cy="237744"/>
           </a:xfrm>
           <a:prstGeom prst="rect">
             <a:avLst/>
@@ -19132,7 +19132,7 @@
         </p:blipFill>
         <p:spPr>
           <a:xfrm>
-            <a:off x="1851660" y="2066544"/>
+            <a:off x="1851660" y="2139696"/>
             <a:ext cx="8458200" cy="3937709"/>
           </a:xfrm>
           <a:prstGeom prst="rect">

</xml_diff>

<commit_message>
docs: documentar el segundo conflicto y aplicar el formato institucional al informe
- Informe con la tipografia, los colores y la caratula del formato de
  referencia: Times New Roman en portada y Calibri Light en titulos.
- Integrantes con nombre completo y codigo UTP.
- Nuevo apartado 3.3 g): el conflicto en Socios.jsx y por que se resolvio
  eligiendo una version en lugar de combinar las dos.
- Cifras al dia: 47 commits, 20 fusiones, 2 conflictos resueltos.
- Presentacion: diapositiva nueva sobre el segundo conflicto (18 en total).

Co-Authored-By: Claude Opus 5 (1M context) <noreply@anthropic.com>
</commit_message>
<xml_diff>
--- a/docs/Avance1-BiblioTech-UTP.pptx
+++ b/docs/Avance1-BiblioTech-UTP.pptx
@@ -22,9 +22,10 @@
     <p:sldId id="270" r:id="rId16"/>
     <p:sldId id="271" r:id="rId17"/>
     <p:sldId id="272" r:id="rId18"/>
+    <p:sldId id="273" r:id="rId19"/>
   </p:sldIdLst>
   <p:notesMasterIdLst>
-    <p:notesMasterId r:id="rId19"/>
+    <p:notesMasterId r:id="rId20"/>
   </p:notesMasterIdLst>
   <p:sldSz cx="12192000" cy="6858000"/>
   <p:notesSz cx="6858000" cy="12192000"/>
@@ -1246,6 +1247,94 @@
             <a:fld id="{F7021451-1387-4CA6-816F-3879F97B5CBC}" type="slidenum">
               <a:rPr lang="en-US"/>
               <a:t>17</a:t>
+            </a:fld>
+            <a:endParaRPr lang="en-US"/>
+          </a:p>
+        </p:txBody>
+      </p:sp>
+    </p:spTree>
+    <p:extLst>
+      <p:ext uri="{BB962C8B-B14F-4D97-AF65-F5344CB8AC3E}">
+        <p14:creationId xmlns:p14="http://schemas.microsoft.com/office/powerpoint/2010/main" val="1024086991"/>
+      </p:ext>
+    </p:extLst>
+  </p:cSld>
+  <p:clrMapOvr>
+    <a:masterClrMapping/>
+  </p:clrMapOvr>
+</p:notes>
+</file>
+
+<file path=ppt/notesSlides/notesSlide18.xml><?xml version="1.0" encoding="utf-8"?>
+<p:notes xmlns:a="http://schemas.openxmlformats.org/drawingml/2006/main" xmlns:r="http://schemas.openxmlformats.org/officeDocument/2006/relationships" xmlns:p="http://schemas.openxmlformats.org/presentationml/2006/main">
+  <p:cSld>
+    <p:spTree>
+      <p:nvGrpSpPr>
+        <p:cNvPr id="1" name=""/>
+        <p:cNvGrpSpPr/>
+        <p:nvPr/>
+      </p:nvGrpSpPr>
+      <p:grpSpPr>
+        <a:xfrm>
+          <a:off x="0" y="0"/>
+          <a:ext cx="0" cy="0"/>
+          <a:chOff x="0" y="0"/>
+          <a:chExt cx="0" cy="0"/>
+        </a:xfrm>
+      </p:grpSpPr>
+      <p:sp>
+        <p:nvSpPr>
+          <p:cNvPr id="2" name="Slide Image Placeholder 1"/>
+          <p:cNvSpPr>
+            <a:spLocks noGrp="1" noRot="1" noChangeAspect="1"/>
+          </p:cNvSpPr>
+          <p:nvPr>
+            <p:ph type="sldImg"/>
+          </p:nvPr>
+        </p:nvSpPr>
+        <p:spPr/>
+      </p:sp>
+      <p:sp>
+        <p:nvSpPr>
+          <p:cNvPr id="3" name="Notes Placeholder 2"/>
+          <p:cNvSpPr>
+            <a:spLocks noGrp="1"/>
+          </p:cNvSpPr>
+          <p:nvPr>
+            <p:ph type="body" idx="1"/>
+          </p:nvPr>
+        </p:nvSpPr>
+        <p:spPr/>
+        <p:txBody>
+          <a:bodyPr/>
+          <a:lstStyle/>
+          <a:p>
+            <a:r>
+              <a:rPr lang="en-US" dirty="0"/>
+              <a:t/>
+            </a:r>
+            <a:endParaRPr lang="en-US" dirty="0"/>
+          </a:p>
+        </p:txBody>
+      </p:sp>
+      <p:sp>
+        <p:nvSpPr>
+          <p:cNvPr id="4" name="Slide Number Placeholder 3"/>
+          <p:cNvSpPr>
+            <a:spLocks noGrp="1"/>
+          </p:cNvSpPr>
+          <p:nvPr>
+            <p:ph type="sldNum" sz="quarter" idx="10"/>
+          </p:nvPr>
+        </p:nvSpPr>
+        <p:spPr/>
+        <p:txBody>
+          <a:bodyPr/>
+          <a:lstStyle/>
+          <a:p>
+            <a:fld id="{F7021451-1387-4CA6-816F-3879F97B5CBC}" type="slidenum">
+              <a:rPr lang="en-US"/>
+              <a:t>18</a:t>
             </a:fld>
             <a:endParaRPr lang="en-US"/>
           </a:p>
@@ -7680,7 +7769,7 @@
                 <a:ea typeface="Calibri" pitchFamily="34" charset="-122"/>
                 <a:cs typeface="Calibri" pitchFamily="34" charset="-120"/>
               </a:rPr>
-              <a:t>05 · RELEASES</a:t>
+              <a:t>04 · GIT EN LA PRÁCTICA</a:t>
             </a:r>
             <a:endParaRPr lang="en-US" sz="1100" dirty="0"/>
           </a:p>
@@ -7719,7 +7808,7 @@
                 <a:ea typeface="Trebuchet MS" pitchFamily="34" charset="-122"/>
                 <a:cs typeface="Trebuchet MS" pitchFamily="34" charset="-120"/>
               </a:rPr>
-              <a:t>Releases, hotfix y un push rechazado</a:t>
+              <a:t>Un segundo conflicto, otra estrategia</a:t>
             </a:r>
             <a:endParaRPr lang="en-US" sz="2900" dirty="0"/>
           </a:p>
@@ -7793,7 +7882,114 @@
         <p:spPr>
           <a:xfrm>
             <a:off x="640080" y="1389888"/>
-            <a:ext cx="2514600" cy="1572768"/>
+            <a:ext cx="10881360" cy="903732"/>
+          </a:xfrm>
+          <a:prstGeom prst="rect">
+            <a:avLst/>
+          </a:prstGeom>
+          <a:solidFill>
+            <a:srgbClr val="3A1A1E"/>
+          </a:solidFill>
+          <a:ln w="12700">
+            <a:solidFill>
+              <a:srgbClr val="6B2B33"/>
+            </a:solidFill>
+            <a:prstDash val="solid"/>
+          </a:ln>
+        </p:spPr>
+      </p:sp>
+      <p:sp>
+        <p:nvSpPr>
+          <p:cNvPr id="7" name="Text 5"/>
+          <p:cNvSpPr/>
+          <p:nvPr/>
+        </p:nvSpPr>
+        <p:spPr>
+          <a:xfrm>
+            <a:off x="786384" y="1508760"/>
+            <a:ext cx="10588752" cy="665988"/>
+          </a:xfrm>
+          <a:prstGeom prst="rect">
+            <a:avLst/>
+          </a:prstGeom>
+          <a:noFill/>
+          <a:ln/>
+        </p:spPr>
+        <p:txBody>
+          <a:bodyPr wrap="square" lIns="0" tIns="0" rIns="0" bIns="0" rtlCol="0" anchor="t"/>
+          <a:lstStyle/>
+          <a:p>
+            <a:pPr indent="0" marL="0">
+              <a:lnSpc>
+                <a:spcPts val="1700"/>
+              </a:lnSpc>
+              <a:buNone/>
+            </a:pPr>
+            <a:r>
+              <a:rPr lang="en-US" sz="1150" dirty="0">
+                <a:solidFill>
+                  <a:srgbClr val="A9C0D6"/>
+                </a:solidFill>
+                <a:latin typeface="Consolas" pitchFamily="34" charset="0"/>
+                <a:ea typeface="Consolas" pitchFamily="34" charset="-122"/>
+                <a:cs typeface="Consolas" pitchFamily="34" charset="-120"/>
+              </a:rPr>
+              <a:t>$ git merge --no-ff feature/gestion-socios</a:t>
+            </a:r>
+            <a:endParaRPr lang="en-US" sz="1150" dirty="0"/>
+          </a:p>
+          <a:p>
+            <a:pPr indent="0" marL="0">
+              <a:lnSpc>
+                <a:spcPts val="1700"/>
+              </a:lnSpc>
+              <a:buNone/>
+            </a:pPr>
+            <a:r>
+              <a:rPr lang="en-US" sz="1150" b="1" dirty="0">
+                <a:solidFill>
+                  <a:srgbClr val="FF9C9C"/>
+                </a:solidFill>
+                <a:latin typeface="Consolas" pitchFamily="34" charset="0"/>
+                <a:ea typeface="Consolas" pitchFamily="34" charset="-122"/>
+                <a:cs typeface="Consolas" pitchFamily="34" charset="-120"/>
+              </a:rPr>
+              <a:t>CONFLICT (content): Merge conflict in frontend/src/pages/Socios.jsx</a:t>
+            </a:r>
+            <a:endParaRPr lang="en-US" sz="1150" dirty="0"/>
+          </a:p>
+          <a:p>
+            <a:pPr indent="0" marL="0">
+              <a:lnSpc>
+                <a:spcPts val="1700"/>
+              </a:lnSpc>
+              <a:buNone/>
+            </a:pPr>
+            <a:r>
+              <a:rPr lang="en-US" sz="1150" dirty="0">
+                <a:solidFill>
+                  <a:srgbClr val="F3BEBE"/>
+                </a:solidFill>
+                <a:latin typeface="Consolas" pitchFamily="34" charset="0"/>
+                <a:ea typeface="Consolas" pitchFamily="34" charset="-122"/>
+                <a:cs typeface="Consolas" pitchFamily="34" charset="-120"/>
+              </a:rPr>
+              <a:t>$ grep -c '&lt;&lt;&lt;&lt;&lt;&lt;&lt;' frontend/src/pages/Socios.jsx        -&gt;  5 bloques</a:t>
+            </a:r>
+            <a:endParaRPr lang="en-US" sz="1150" dirty="0"/>
+          </a:p>
+        </p:txBody>
+      </p:sp>
+      <p:sp>
+        <p:nvSpPr>
+          <p:cNvPr id="8" name="Shape 6"/>
+          <p:cNvSpPr/>
+          <p:nvPr/>
+        </p:nvSpPr>
+        <p:spPr>
+          <a:xfrm>
+            <a:off x="640080" y="2604516"/>
+            <a:ext cx="5303520" cy="2057400"/>
           </a:xfrm>
           <a:prstGeom prst="rect">
             <a:avLst/>
@@ -7818,14 +8014,14 @@
       </p:sp>
       <p:sp>
         <p:nvSpPr>
-          <p:cNvPr id="7" name="Shape 5"/>
-          <p:cNvSpPr/>
-          <p:nvPr/>
-        </p:nvSpPr>
-        <p:spPr>
-          <a:xfrm>
-            <a:off x="640080" y="1389888"/>
-            <a:ext cx="68580" cy="1572768"/>
+          <p:cNvPr id="9" name="Shape 7"/>
+          <p:cNvSpPr/>
+          <p:nvPr/>
+        </p:nvSpPr>
+        <p:spPr>
+          <a:xfrm>
+            <a:off x="640080" y="2604516"/>
+            <a:ext cx="68580" cy="2057400"/>
           </a:xfrm>
           <a:prstGeom prst="rect">
             <a:avLst/>
@@ -7838,108 +8034,106 @@
       </p:sp>
       <p:sp>
         <p:nvSpPr>
-          <p:cNvPr id="8" name="Text 6"/>
-          <p:cNvSpPr/>
-          <p:nvPr/>
-        </p:nvSpPr>
-        <p:spPr>
-          <a:xfrm>
-            <a:off x="841248" y="1481328"/>
-            <a:ext cx="2194560" cy="347472"/>
-          </a:xfrm>
-          <a:prstGeom prst="rect">
-            <a:avLst/>
-          </a:prstGeom>
-          <a:noFill/>
-          <a:ln/>
-        </p:spPr>
-        <p:txBody>
-          <a:bodyPr wrap="square" lIns="0" tIns="0" rIns="0" bIns="0" rtlCol="0" anchor="ctr"/>
-          <a:lstStyle/>
-          <a:p>
-            <a:pPr indent="0" marL="0">
-              <a:buNone/>
-            </a:pPr>
-            <a:r>
-              <a:rPr lang="en-US" sz="1600" b="1" dirty="0">
-                <a:solidFill>
-                  <a:srgbClr val="C8102E"/>
+          <p:cNvPr id="10" name="Text 8"/>
+          <p:cNvSpPr/>
+          <p:nvPr/>
+        </p:nvSpPr>
+        <p:spPr>
+          <a:xfrm>
+            <a:off x="841248" y="2732532"/>
+            <a:ext cx="4901184" cy="274320"/>
+          </a:xfrm>
+          <a:prstGeom prst="rect">
+            <a:avLst/>
+          </a:prstGeom>
+          <a:noFill/>
+          <a:ln/>
+        </p:spPr>
+        <p:txBody>
+          <a:bodyPr wrap="square" lIns="0" tIns="0" rIns="0" bIns="0" rtlCol="0" anchor="ctr"/>
+          <a:lstStyle/>
+          <a:p>
+            <a:pPr indent="0" marL="0">
+              <a:buNone/>
+            </a:pPr>
+            <a:r>
+              <a:rPr lang="en-US" sz="1300" b="1" dirty="0">
+                <a:solidFill>
+                  <a:srgbClr val="0F172A"/>
+                </a:solidFill>
+                <a:latin typeface="Trebuchet MS" pitchFamily="34" charset="0"/>
+                <a:ea typeface="Trebuchet MS" pitchFamily="34" charset="-122"/>
+                <a:cs typeface="Trebuchet MS" pitchFamily="34" charset="-120"/>
+              </a:rPr>
+              <a:t>HEAD — develop  ·  140 líneas</a:t>
+            </a:r>
+            <a:endParaRPr lang="en-US" sz="1300" dirty="0"/>
+          </a:p>
+        </p:txBody>
+      </p:sp>
+      <p:sp>
+        <p:nvSpPr>
+          <p:cNvPr id="11" name="Text 9"/>
+          <p:cNvSpPr/>
+          <p:nvPr/>
+        </p:nvSpPr>
+        <p:spPr>
+          <a:xfrm>
+            <a:off x="841248" y="3061716"/>
+            <a:ext cx="4901184" cy="1463040"/>
+          </a:xfrm>
+          <a:prstGeom prst="rect">
+            <a:avLst/>
+          </a:prstGeom>
+          <a:noFill/>
+          <a:ln/>
+        </p:spPr>
+        <p:txBody>
+          <a:bodyPr wrap="square" lIns="0" tIns="0" rIns="0" bIns="0" rtlCol="0" anchor="t"/>
+          <a:lstStyle/>
+          <a:p>
+            <a:pPr indent="0" marL="0">
+              <a:lnSpc>
+                <a:spcPts val="1600"/>
+              </a:lnSpc>
+              <a:buNone/>
+            </a:pPr>
+            <a:r>
+              <a:rPr lang="en-US" sz="1150" dirty="0">
+                <a:solidFill>
+                  <a:srgbClr val="55606E"/>
+                </a:solidFill>
+                <a:latin typeface="Calibri" pitchFamily="34" charset="0"/>
+                <a:ea typeface="Calibri" pitchFamily="34" charset="-122"/>
+                <a:cs typeface="Calibri" pitchFamily="34" charset="-120"/>
+              </a:rPr>
+              <a:t>✗  Enviaba </a:t>
+            </a:r>
+            <a:pPr indent="0" marL="0">
+              <a:lnSpc>
+                <a:spcPts val="1600"/>
+              </a:lnSpc>
+              <a:buNone/>
+            </a:pPr>
+            <a:r>
+              <a:rPr lang="en-US" sz="1150" dirty="0">
+                <a:solidFill>
+                  <a:srgbClr val="55606E"/>
                 </a:solidFill>
                 <a:latin typeface="Consolas" pitchFamily="34" charset="0"/>
                 <a:ea typeface="Consolas" pitchFamily="34" charset="-122"/>
                 <a:cs typeface="Consolas" pitchFamily="34" charset="-120"/>
               </a:rPr>
-              <a:t>v1.0.0</a:t>
-            </a:r>
-            <a:endParaRPr lang="en-US" sz="1600" dirty="0"/>
-          </a:p>
-        </p:txBody>
-      </p:sp>
-      <p:sp>
-        <p:nvSpPr>
-          <p:cNvPr id="9" name="Text 7"/>
-          <p:cNvSpPr/>
-          <p:nvPr/>
-        </p:nvSpPr>
-        <p:spPr>
-          <a:xfrm>
-            <a:off x="841248" y="1847088"/>
-            <a:ext cx="2194560" cy="237744"/>
-          </a:xfrm>
-          <a:prstGeom prst="rect">
-            <a:avLst/>
-          </a:prstGeom>
-          <a:noFill/>
-          <a:ln/>
-        </p:spPr>
-        <p:txBody>
-          <a:bodyPr wrap="square" lIns="0" tIns="0" rIns="0" bIns="0" rtlCol="0" anchor="ctr"/>
-          <a:lstStyle/>
-          <a:p>
-            <a:pPr indent="0" marL="0">
-              <a:buNone/>
-            </a:pPr>
-            <a:r>
-              <a:rPr lang="en-US" sz="1150" b="1" dirty="0">
-                <a:solidFill>
-                  <a:srgbClr val="0F172A"/>
-                </a:solidFill>
-                <a:latin typeface="Trebuchet MS" pitchFamily="34" charset="0"/>
-                <a:ea typeface="Trebuchet MS" pitchFamily="34" charset="-122"/>
-                <a:cs typeface="Trebuchet MS" pitchFamily="34" charset="-120"/>
-              </a:rPr>
-              <a:t>Primer release</a:t>
-            </a:r>
-            <a:endParaRPr lang="en-US" sz="1150" dirty="0"/>
-          </a:p>
-        </p:txBody>
-      </p:sp>
-      <p:sp>
-        <p:nvSpPr>
-          <p:cNvPr id="10" name="Text 8"/>
-          <p:cNvSpPr/>
-          <p:nvPr/>
-        </p:nvSpPr>
-        <p:spPr>
-          <a:xfrm>
-            <a:off x="841248" y="2121408"/>
-            <a:ext cx="2194560" cy="731520"/>
-          </a:xfrm>
-          <a:prstGeom prst="rect">
-            <a:avLst/>
-          </a:prstGeom>
-          <a:noFill/>
-          <a:ln/>
-        </p:spPr>
-        <p:txBody>
-          <a:bodyPr wrap="square" lIns="0" tIns="0" rIns="0" bIns="0" rtlCol="0" anchor="ctr"/>
-          <a:lstStyle/>
-          <a:p>
-            <a:pPr indent="0" marL="0">
-              <a:buNone/>
-            </a:pPr>
-            <a:r>
-              <a:rPr lang="en-US" sz="1050" dirty="0">
+              <a:t>tipo_socio: "Estudiante"</a:t>
+            </a:r>
+            <a:pPr indent="0" marL="0">
+              <a:lnSpc>
+                <a:spcPts val="1600"/>
+              </a:lnSpc>
+              <a:buNone/>
+            </a:pPr>
+            <a:r>
+              <a:rPr lang="en-US" sz="1150" dirty="0">
                 <a:solidFill>
                   <a:srgbClr val="55606E"/>
                 </a:solidFill>
@@ -7947,35 +8141,65 @@
                 <a:ea typeface="Calibri" pitchFamily="34" charset="-122"/>
                 <a:cs typeface="Calibri" pitchFamily="34" charset="-120"/>
               </a:rPr>
-              <a:t>Los 4 módulos integrados y etiquetados en main</a:t>
-            </a:r>
-            <a:endParaRPr lang="en-US" sz="1050" dirty="0"/>
-          </a:p>
-        </p:txBody>
-      </p:sp>
-      <p:sp>
-        <p:nvSpPr>
-          <p:cNvPr id="11" name="Shape 9"/>
-          <p:cNvSpPr/>
-          <p:nvPr/>
-        </p:nvSpPr>
-        <p:spPr>
-          <a:xfrm>
-            <a:off x="3218688" y="2176272"/>
-            <a:ext cx="155448" cy="0"/>
-          </a:xfrm>
-          <a:prstGeom prst="line">
-            <a:avLst/>
-          </a:prstGeom>
-          <a:noFill/>
-          <a:ln w="25400">
-            <a:solidFill>
-              <a:srgbClr val="8A97A6"/>
-            </a:solidFill>
-            <a:prstDash val="solid"/>
-            <a:tailEnd type="triangle"/>
-          </a:ln>
-        </p:spPr>
+              <a:t>  — la API valida </a:t>
+            </a:r>
+            <a:pPr indent="0" marL="0">
+              <a:lnSpc>
+                <a:spcPts val="1600"/>
+              </a:lnSpc>
+              <a:buNone/>
+            </a:pPr>
+            <a:r>
+              <a:rPr lang="en-US" sz="1150" dirty="0">
+                <a:solidFill>
+                  <a:srgbClr val="55606E"/>
+                </a:solidFill>
+                <a:latin typeface="Consolas" pitchFamily="34" charset="0"/>
+                <a:ea typeface="Consolas" pitchFamily="34" charset="-122"/>
+                <a:cs typeface="Consolas" pitchFamily="34" charset="-120"/>
+              </a:rPr>
+              <a:t>tipo</a:t>
+            </a:r>
+            <a:pPr indent="0" marL="0">
+              <a:lnSpc>
+                <a:spcPts val="1600"/>
+              </a:lnSpc>
+              <a:buNone/>
+            </a:pPr>
+            <a:r>
+              <a:rPr lang="en-US" sz="1150" dirty="0">
+                <a:solidFill>
+                  <a:srgbClr val="55606E"/>
+                </a:solidFill>
+                <a:latin typeface="Calibri" pitchFamily="34" charset="0"/>
+                <a:ea typeface="Calibri" pitchFamily="34" charset="-122"/>
+                <a:cs typeface="Calibri" pitchFamily="34" charset="-120"/>
+              </a:rPr>
+              <a:t> en minúsculas, así que el alta fallaba siempre.</a:t>
+            </a:r>
+            <a:endParaRPr lang="en-US" sz="1150" dirty="0"/>
+          </a:p>
+          <a:p>
+            <a:pPr indent="0" marL="0">
+              <a:lnSpc>
+                <a:spcPts val="1600"/>
+              </a:lnSpc>
+              <a:buNone/>
+            </a:pPr>
+            <a:r>
+              <a:rPr lang="en-US" sz="1150" dirty="0">
+                <a:solidFill>
+                  <a:srgbClr val="55606E"/>
+                </a:solidFill>
+                <a:latin typeface="Calibri" pitchFamily="34" charset="0"/>
+                <a:ea typeface="Calibri" pitchFamily="34" charset="-122"/>
+                <a:cs typeface="Calibri" pitchFamily="34" charset="-120"/>
+              </a:rPr>
+              <a:t>✗  Había perdido editar socio y suspender / reactivar.</a:t>
+            </a:r>
+            <a:endParaRPr lang="en-US" sz="1150" dirty="0"/>
+          </a:p>
+        </p:txBody>
       </p:sp>
       <p:sp>
         <p:nvSpPr>
@@ -7985,8 +8209,8 @@
         </p:nvSpPr>
         <p:spPr>
           <a:xfrm>
-            <a:off x="3429000" y="1389888"/>
-            <a:ext cx="2514600" cy="1572768"/>
+            <a:off x="6217920" y="2604516"/>
+            <a:ext cx="5303520" cy="2057400"/>
           </a:xfrm>
           <a:prstGeom prst="rect">
             <a:avLst/>
@@ -8017,14 +8241,14 @@
         </p:nvSpPr>
         <p:spPr>
           <a:xfrm>
-            <a:off x="3429000" y="1389888"/>
-            <a:ext cx="68580" cy="1572768"/>
+            <a:off x="6217920" y="2604516"/>
+            <a:ext cx="68580" cy="2057400"/>
           </a:xfrm>
           <a:prstGeom prst="rect">
             <a:avLst/>
           </a:prstGeom>
           <a:solidFill>
-            <a:srgbClr val="D97706"/>
+            <a:srgbClr val="2E9E6B"/>
           </a:solidFill>
           <a:ln/>
         </p:spPr>
@@ -8037,102 +8261,100 @@
         </p:nvSpPr>
         <p:spPr>
           <a:xfrm>
-            <a:off x="3630168" y="1481328"/>
-            <a:ext cx="2194560" cy="347472"/>
-          </a:xfrm>
-          <a:prstGeom prst="rect">
-            <a:avLst/>
-          </a:prstGeom>
-          <a:noFill/>
-          <a:ln/>
-        </p:spPr>
-        <p:txBody>
-          <a:bodyPr wrap="square" lIns="0" tIns="0" rIns="0" bIns="0" rtlCol="0" anchor="ctr"/>
-          <a:lstStyle/>
-          <a:p>
-            <a:pPr indent="0" marL="0">
-              <a:buNone/>
-            </a:pPr>
-            <a:r>
-              <a:rPr lang="en-US" sz="1600" b="1" dirty="0">
-                <a:solidFill>
-                  <a:srgbClr val="D97706"/>
+            <a:off x="6419088" y="2732532"/>
+            <a:ext cx="4901184" cy="274320"/>
+          </a:xfrm>
+          <a:prstGeom prst="rect">
+            <a:avLst/>
+          </a:prstGeom>
+          <a:noFill/>
+          <a:ln/>
+        </p:spPr>
+        <p:txBody>
+          <a:bodyPr wrap="square" lIns="0" tIns="0" rIns="0" bIns="0" rtlCol="0" anchor="ctr"/>
+          <a:lstStyle/>
+          <a:p>
+            <a:pPr indent="0" marL="0">
+              <a:buNone/>
+            </a:pPr>
+            <a:r>
+              <a:rPr lang="en-US" sz="1300" b="1" dirty="0">
+                <a:solidFill>
+                  <a:srgbClr val="0F172A"/>
+                </a:solidFill>
+                <a:latin typeface="Trebuchet MS" pitchFamily="34" charset="0"/>
+                <a:ea typeface="Trebuchet MS" pitchFamily="34" charset="-122"/>
+                <a:cs typeface="Trebuchet MS" pitchFamily="34" charset="-120"/>
+              </a:rPr>
+              <a:t>feature/gestion-socios  ·  681 líneas</a:t>
+            </a:r>
+            <a:endParaRPr lang="en-US" sz="1300" dirty="0"/>
+          </a:p>
+        </p:txBody>
+      </p:sp>
+      <p:sp>
+        <p:nvSpPr>
+          <p:cNvPr id="15" name="Text 13"/>
+          <p:cNvSpPr/>
+          <p:nvPr/>
+        </p:nvSpPr>
+        <p:spPr>
+          <a:xfrm>
+            <a:off x="6419088" y="3061716"/>
+            <a:ext cx="4901184" cy="1463040"/>
+          </a:xfrm>
+          <a:prstGeom prst="rect">
+            <a:avLst/>
+          </a:prstGeom>
+          <a:noFill/>
+          <a:ln/>
+        </p:spPr>
+        <p:txBody>
+          <a:bodyPr wrap="square" lIns="0" tIns="0" rIns="0" bIns="0" rtlCol="0" anchor="t"/>
+          <a:lstStyle/>
+          <a:p>
+            <a:pPr indent="0" marL="0">
+              <a:lnSpc>
+                <a:spcPts val="1600"/>
+              </a:lnSpc>
+              <a:buNone/>
+            </a:pPr>
+            <a:r>
+              <a:rPr lang="en-US" sz="1150" dirty="0">
+                <a:solidFill>
+                  <a:srgbClr val="55606E"/>
+                </a:solidFill>
+                <a:latin typeface="Calibri" pitchFamily="34" charset="0"/>
+                <a:ea typeface="Calibri" pitchFamily="34" charset="-122"/>
+                <a:cs typeface="Calibri" pitchFamily="34" charset="-120"/>
+              </a:rPr>
+              <a:t>✓  Campo </a:t>
+            </a:r>
+            <a:pPr indent="0" marL="0">
+              <a:lnSpc>
+                <a:spcPts val="1600"/>
+              </a:lnSpc>
+              <a:buNone/>
+            </a:pPr>
+            <a:r>
+              <a:rPr lang="en-US" sz="1150" dirty="0">
+                <a:solidFill>
+                  <a:srgbClr val="55606E"/>
                 </a:solidFill>
                 <a:latin typeface="Consolas" pitchFamily="34" charset="0"/>
                 <a:ea typeface="Consolas" pitchFamily="34" charset="-122"/>
                 <a:cs typeface="Consolas" pitchFamily="34" charset="-120"/>
               </a:rPr>
-              <a:t>Bug</a:t>
-            </a:r>
-            <a:endParaRPr lang="en-US" sz="1600" dirty="0"/>
-          </a:p>
-        </p:txBody>
-      </p:sp>
-      <p:sp>
-        <p:nvSpPr>
-          <p:cNvPr id="15" name="Text 13"/>
-          <p:cNvSpPr/>
-          <p:nvPr/>
-        </p:nvSpPr>
-        <p:spPr>
-          <a:xfrm>
-            <a:off x="3630168" y="1847088"/>
-            <a:ext cx="2194560" cy="237744"/>
-          </a:xfrm>
-          <a:prstGeom prst="rect">
-            <a:avLst/>
-          </a:prstGeom>
-          <a:noFill/>
-          <a:ln/>
-        </p:spPr>
-        <p:txBody>
-          <a:bodyPr wrap="square" lIns="0" tIns="0" rIns="0" bIns="0" rtlCol="0" anchor="ctr"/>
-          <a:lstStyle/>
-          <a:p>
-            <a:pPr indent="0" marL="0">
-              <a:buNone/>
-            </a:pPr>
-            <a:r>
-              <a:rPr lang="en-US" sz="1150" b="1" dirty="0">
-                <a:solidFill>
-                  <a:srgbClr val="0F172A"/>
-                </a:solidFill>
-                <a:latin typeface="Trebuchet MS" pitchFamily="34" charset="0"/>
-                <a:ea typeface="Trebuchet MS" pitchFamily="34" charset="-122"/>
-                <a:cs typeface="Trebuchet MS" pitchFamily="34" charset="-120"/>
-              </a:rPr>
-              <a:t>Detectado en pruebas</a:t>
-            </a:r>
-            <a:endParaRPr lang="en-US" sz="1150" dirty="0"/>
-          </a:p>
-        </p:txBody>
-      </p:sp>
-      <p:sp>
-        <p:nvSpPr>
-          <p:cNvPr id="16" name="Text 14"/>
-          <p:cNvSpPr/>
-          <p:nvPr/>
-        </p:nvSpPr>
-        <p:spPr>
-          <a:xfrm>
-            <a:off x="3630168" y="2121408"/>
-            <a:ext cx="2194560" cy="731520"/>
-          </a:xfrm>
-          <a:prstGeom prst="rect">
-            <a:avLst/>
-          </a:prstGeom>
-          <a:noFill/>
-          <a:ln/>
-        </p:spPr>
-        <p:txBody>
-          <a:bodyPr wrap="square" lIns="0" tIns="0" rIns="0" bIns="0" rtlCol="0" anchor="ctr"/>
-          <a:lstStyle/>
-          <a:p>
-            <a:pPr indent="0" marL="0">
-              <a:buNone/>
-            </a:pPr>
-            <a:r>
-              <a:rPr lang="en-US" sz="1050" dirty="0">
+              <a:t>tipo: "estudiante"</a:t>
+            </a:r>
+            <a:pPr indent="0" marL="0">
+              <a:lnSpc>
+                <a:spcPts val="1600"/>
+              </a:lnSpc>
+              <a:buNone/>
+            </a:pPr>
+            <a:r>
+              <a:rPr lang="en-US" sz="1150" dirty="0">
                 <a:solidFill>
                   <a:srgbClr val="55606E"/>
                 </a:solidFill>
@@ -8140,46 +8362,62 @@
                 <a:ea typeface="Calibri" pitchFamily="34" charset="-122"/>
                 <a:cs typeface="Calibri" pitchFamily="34" charset="-120"/>
               </a:rPr>
-              <a:t>La API devolvía HTML en vez de JSON</a:t>
-            </a:r>
-            <a:endParaRPr lang="en-US" sz="1050" dirty="0"/>
-          </a:p>
-        </p:txBody>
-      </p:sp>
-      <p:sp>
-        <p:nvSpPr>
-          <p:cNvPr id="17" name="Shape 15"/>
-          <p:cNvSpPr/>
-          <p:nvPr/>
-        </p:nvSpPr>
-        <p:spPr>
-          <a:xfrm>
-            <a:off x="6007608" y="2176272"/>
-            <a:ext cx="155448" cy="0"/>
-          </a:xfrm>
-          <a:prstGeom prst="line">
-            <a:avLst/>
-          </a:prstGeom>
-          <a:noFill/>
-          <a:ln w="25400">
-            <a:solidFill>
-              <a:srgbClr val="8A97A6"/>
-            </a:solidFill>
-            <a:prstDash val="solid"/>
-            <a:tailEnd type="triangle"/>
-          </a:ln>
-        </p:spPr>
-      </p:sp>
-      <p:sp>
-        <p:nvSpPr>
-          <p:cNvPr id="18" name="Shape 16"/>
-          <p:cNvSpPr/>
-          <p:nvPr/>
-        </p:nvSpPr>
-        <p:spPr>
-          <a:xfrm>
-            <a:off x="6217920" y="1389888"/>
-            <a:ext cx="2514600" cy="1572768"/>
+              <a:t>  — correcto contra la API.</a:t>
+            </a:r>
+            <a:endParaRPr lang="en-US" sz="1150" dirty="0"/>
+          </a:p>
+          <a:p>
+            <a:pPr indent="0" marL="0">
+              <a:lnSpc>
+                <a:spcPts val="1600"/>
+              </a:lnSpc>
+              <a:buNone/>
+            </a:pPr>
+            <a:r>
+              <a:rPr lang="en-US" sz="1150" dirty="0">
+                <a:solidFill>
+                  <a:srgbClr val="55606E"/>
+                </a:solidFill>
+                <a:latin typeface="Calibri" pitchFamily="34" charset="0"/>
+                <a:ea typeface="Calibri" pitchFamily="34" charset="-122"/>
+                <a:cs typeface="Calibri" pitchFamily="34" charset="-120"/>
+              </a:rPr>
+              <a:t>✓  CRUD completo: listar, crear, editar y cambiar estado.</a:t>
+            </a:r>
+            <a:endParaRPr lang="en-US" sz="1150" dirty="0"/>
+          </a:p>
+          <a:p>
+            <a:pPr indent="0" marL="0">
+              <a:lnSpc>
+                <a:spcPts val="1600"/>
+              </a:lnSpc>
+              <a:buNone/>
+            </a:pPr>
+            <a:r>
+              <a:rPr lang="en-US" sz="1150" dirty="0">
+                <a:solidFill>
+                  <a:srgbClr val="55606E"/>
+                </a:solidFill>
+                <a:latin typeface="Calibri" pitchFamily="34" charset="0"/>
+                <a:ea typeface="Calibri" pitchFamily="34" charset="-122"/>
+                <a:cs typeface="Calibri" pitchFamily="34" charset="-120"/>
+              </a:rPr>
+              <a:t>✓  Rediseño con modal, filtros y tarjetas de indicadores.</a:t>
+            </a:r>
+            <a:endParaRPr lang="en-US" sz="1150" dirty="0"/>
+          </a:p>
+        </p:txBody>
+      </p:sp>
+      <p:sp>
+        <p:nvSpPr>
+          <p:cNvPr id="16" name="Shape 14"/>
+          <p:cNvSpPr/>
+          <p:nvPr/>
+        </p:nvSpPr>
+        <p:spPr>
+          <a:xfrm>
+            <a:off x="640080" y="4936236"/>
+            <a:ext cx="10881360" cy="1097280"/>
           </a:xfrm>
           <a:prstGeom prst="rect">
             <a:avLst/>
@@ -8204,89 +8442,50 @@
       </p:sp>
       <p:sp>
         <p:nvSpPr>
-          <p:cNvPr id="19" name="Shape 17"/>
-          <p:cNvSpPr/>
-          <p:nvPr/>
-        </p:nvSpPr>
-        <p:spPr>
-          <a:xfrm>
-            <a:off x="6217920" y="1389888"/>
-            <a:ext cx="68580" cy="1572768"/>
+          <p:cNvPr id="17" name="Shape 15"/>
+          <p:cNvSpPr/>
+          <p:nvPr/>
+        </p:nvSpPr>
+        <p:spPr>
+          <a:xfrm>
+            <a:off x="640080" y="4936236"/>
+            <a:ext cx="68580" cy="1097280"/>
           </a:xfrm>
           <a:prstGeom prst="rect">
             <a:avLst/>
           </a:prstGeom>
           <a:solidFill>
-            <a:srgbClr val="7C3AED"/>
+            <a:srgbClr val="3B82F6"/>
           </a:solidFill>
           <a:ln/>
         </p:spPr>
       </p:sp>
       <p:sp>
         <p:nvSpPr>
-          <p:cNvPr id="20" name="Text 18"/>
-          <p:cNvSpPr/>
-          <p:nvPr/>
-        </p:nvSpPr>
-        <p:spPr>
-          <a:xfrm>
-            <a:off x="6419088" y="1481328"/>
-            <a:ext cx="2194560" cy="347472"/>
-          </a:xfrm>
-          <a:prstGeom prst="rect">
-            <a:avLst/>
-          </a:prstGeom>
-          <a:noFill/>
-          <a:ln/>
-        </p:spPr>
-        <p:txBody>
-          <a:bodyPr wrap="square" lIns="0" tIns="0" rIns="0" bIns="0" rtlCol="0" anchor="ctr"/>
-          <a:lstStyle/>
-          <a:p>
-            <a:pPr indent="0" marL="0">
-              <a:buNone/>
-            </a:pPr>
-            <a:r>
-              <a:rPr lang="en-US" sz="1600" b="1" dirty="0">
-                <a:solidFill>
-                  <a:srgbClr val="7C3AED"/>
-                </a:solidFill>
-                <a:latin typeface="Consolas" pitchFamily="34" charset="0"/>
-                <a:ea typeface="Consolas" pitchFamily="34" charset="-122"/>
-                <a:cs typeface="Consolas" pitchFamily="34" charset="-120"/>
-              </a:rPr>
-              <a:t>hotfix</a:t>
-            </a:r>
-            <a:endParaRPr lang="en-US" sz="1600" dirty="0"/>
-          </a:p>
-        </p:txBody>
-      </p:sp>
-      <p:sp>
-        <p:nvSpPr>
-          <p:cNvPr id="21" name="Text 19"/>
-          <p:cNvSpPr/>
-          <p:nvPr/>
-        </p:nvSpPr>
-        <p:spPr>
-          <a:xfrm>
-            <a:off x="6419088" y="1847088"/>
-            <a:ext cx="2194560" cy="237744"/>
-          </a:xfrm>
-          <a:prstGeom prst="rect">
-            <a:avLst/>
-          </a:prstGeom>
-          <a:noFill/>
-          <a:ln/>
-        </p:spPr>
-        <p:txBody>
-          <a:bodyPr wrap="square" lIns="0" tIns="0" rIns="0" bIns="0" rtlCol="0" anchor="ctr"/>
-          <a:lstStyle/>
-          <a:p>
-            <a:pPr indent="0" marL="0">
-              <a:buNone/>
-            </a:pPr>
-            <a:r>
-              <a:rPr lang="en-US" sz="1150" b="1" dirty="0">
+          <p:cNvPr id="18" name="Text 16"/>
+          <p:cNvSpPr/>
+          <p:nvPr/>
+        </p:nvSpPr>
+        <p:spPr>
+          <a:xfrm>
+            <a:off x="841248" y="5055108"/>
+            <a:ext cx="10479024" cy="274320"/>
+          </a:xfrm>
+          <a:prstGeom prst="rect">
+            <a:avLst/>
+          </a:prstGeom>
+          <a:noFill/>
+          <a:ln/>
+        </p:spPr>
+        <p:txBody>
+          <a:bodyPr wrap="square" lIns="0" tIns="0" rIns="0" bIns="0" rtlCol="0" anchor="ctr"/>
+          <a:lstStyle/>
+          <a:p>
+            <a:pPr indent="0" marL="0">
+              <a:buNone/>
+            </a:pPr>
+            <a:r>
+              <a:rPr lang="en-US" sz="1400" b="1" dirty="0">
                 <a:solidFill>
                   <a:srgbClr val="0F172A"/>
                 </a:solidFill>
@@ -8294,38 +8493,38 @@
                 <a:ea typeface="Trebuchet MS" pitchFamily="34" charset="-122"/>
                 <a:cs typeface="Trebuchet MS" pitchFamily="34" charset="-120"/>
               </a:rPr>
-              <a:t>Rama desde main</a:t>
-            </a:r>
-            <a:endParaRPr lang="en-US" sz="1150" dirty="0"/>
-          </a:p>
-        </p:txBody>
-      </p:sp>
-      <p:sp>
-        <p:nvSpPr>
-          <p:cNvPr id="22" name="Text 20"/>
-          <p:cNvSpPr/>
-          <p:nvPr/>
-        </p:nvSpPr>
-        <p:spPr>
-          <a:xfrm>
-            <a:off x="6419088" y="2121408"/>
-            <a:ext cx="2194560" cy="731520"/>
-          </a:xfrm>
-          <a:prstGeom prst="rect">
-            <a:avLst/>
-          </a:prstGeom>
-          <a:noFill/>
-          <a:ln/>
-        </p:spPr>
-        <p:txBody>
-          <a:bodyPr wrap="square" lIns="0" tIns="0" rIns="0" bIns="0" rtlCol="0" anchor="ctr"/>
-          <a:lstStyle/>
-          <a:p>
-            <a:pPr indent="0" marL="0">
-              <a:buNone/>
-            </a:pPr>
-            <a:r>
-              <a:rPr lang="en-US" sz="1050" dirty="0">
+              <a:t>La regla no es «combinar siempre»</a:t>
+            </a:r>
+            <a:endParaRPr lang="en-US" sz="1400" dirty="0"/>
+          </a:p>
+        </p:txBody>
+      </p:sp>
+      <p:sp>
+        <p:nvSpPr>
+          <p:cNvPr id="19" name="Text 17"/>
+          <p:cNvSpPr/>
+          <p:nvPr/>
+        </p:nvSpPr>
+        <p:spPr>
+          <a:xfrm>
+            <a:off x="841248" y="5347716"/>
+            <a:ext cx="10479024" cy="566928"/>
+          </a:xfrm>
+          <a:prstGeom prst="rect">
+            <a:avLst/>
+          </a:prstGeom>
+          <a:noFill/>
+          <a:ln/>
+        </p:spPr>
+        <p:txBody>
+          <a:bodyPr wrap="square" lIns="0" tIns="0" rIns="0" bIns="0" rtlCol="0" anchor="t"/>
+          <a:lstStyle/>
+          <a:p>
+            <a:pPr indent="0" marL="0">
+              <a:buNone/>
+            </a:pPr>
+            <a:r>
+              <a:rPr lang="en-US" sz="1200" dirty="0">
                 <a:solidFill>
                   <a:srgbClr val="55606E"/>
                 </a:solidFill>
@@ -8333,45 +8532,229 @@
                 <a:ea typeface="Calibri" pitchFamily="34" charset="-122"/>
                 <a:cs typeface="Calibri" pitchFamily="34" charset="-120"/>
               </a:rPr>
-              <a:t>Corrección aislada, sin arrastrar develop</a:t>
-            </a:r>
-            <a:endParaRPr lang="en-US" sz="1050" dirty="0"/>
-          </a:p>
-        </p:txBody>
-      </p:sp>
-      <p:sp>
-        <p:nvSpPr>
-          <p:cNvPr id="23" name="Shape 21"/>
-          <p:cNvSpPr/>
-          <p:nvPr/>
-        </p:nvSpPr>
-        <p:spPr>
-          <a:xfrm>
-            <a:off x="8796528" y="2176272"/>
-            <a:ext cx="155448" cy="0"/>
-          </a:xfrm>
-          <a:prstGeom prst="line">
-            <a:avLst/>
-          </a:prstGeom>
-          <a:noFill/>
-          <a:ln w="25400">
-            <a:solidFill>
-              <a:srgbClr val="8A97A6"/>
-            </a:solidFill>
-            <a:prstDash val="solid"/>
-            <a:tailEnd type="triangle"/>
-          </a:ln>
-        </p:spPr>
-      </p:sp>
-      <p:sp>
-        <p:nvSpPr>
-          <p:cNvPr id="24" name="Shape 22"/>
-          <p:cNvSpPr/>
-          <p:nvPr/>
-        </p:nvSpPr>
-        <p:spPr>
-          <a:xfrm>
-            <a:off x="9006840" y="1389888"/>
+              <a:t>En Navbar.jsx las dos ramas aportaban cosas distintas y se combinaron. Aquí eran versiones alternativas del mismo componente: hubo que elegir, y el criterio fue verificable — comparar cada versión contra la validación real de la API, no decidir por antigüedad ni por preferencia.</a:t>
+            </a:r>
+            <a:endParaRPr lang="en-US" sz="1200" dirty="0"/>
+          </a:p>
+        </p:txBody>
+      </p:sp>
+      <p:sp>
+        <p:nvSpPr>
+          <p:cNvPr id="20" name="Text 18"/>
+          <p:cNvSpPr/>
+          <p:nvPr/>
+        </p:nvSpPr>
+        <p:spPr>
+          <a:xfrm>
+            <a:off x="640080" y="6382512"/>
+            <a:ext cx="6400800" cy="274320"/>
+          </a:xfrm>
+          <a:prstGeom prst="rect">
+            <a:avLst/>
+          </a:prstGeom>
+          <a:noFill/>
+          <a:ln/>
+        </p:spPr>
+        <p:txBody>
+          <a:bodyPr wrap="square" lIns="0" tIns="0" rIns="0" bIns="0" rtlCol="0" anchor="ctr"/>
+          <a:lstStyle/>
+          <a:p>
+            <a:pPr indent="0" marL="0">
+              <a:buNone/>
+            </a:pPr>
+            <a:r>
+              <a:rPr lang="en-US" sz="950" dirty="0">
+                <a:solidFill>
+                  <a:srgbClr val="55606E"/>
+                </a:solidFill>
+                <a:latin typeface="Calibri" pitchFamily="34" charset="0"/>
+                <a:ea typeface="Calibri" pitchFamily="34" charset="-122"/>
+                <a:cs typeface="Calibri" pitchFamily="34" charset="-120"/>
+              </a:rPr>
+              <a:t>BiblioTech UTP  ·  Herramientas de Desarrollo  ·  Avance 1</a:t>
+            </a:r>
+            <a:endParaRPr lang="en-US" sz="950" dirty="0"/>
+          </a:p>
+        </p:txBody>
+      </p:sp>
+    </p:spTree>
+  </p:cSld>
+  <p:clrMapOvr>
+    <a:masterClrMapping/>
+  </p:clrMapOvr>
+</p:sld>
+</file>
+
+<file path=ppt/slides/slide15.xml><?xml version="1.0" encoding="utf-8"?>
+<p:sld xmlns:a="http://schemas.openxmlformats.org/drawingml/2006/main" xmlns:r="http://schemas.openxmlformats.org/officeDocument/2006/relationships" xmlns:p="http://schemas.openxmlformats.org/presentationml/2006/main">
+  <p:cSld name="Slide 15">
+    <p:bg>
+      <p:bgPr>
+        <a:solidFill>
+          <a:srgbClr val="F4F6FA"/>
+        </a:solidFill>
+      </p:bgPr>
+    </p:bg>
+    <p:spTree>
+      <p:nvGrpSpPr>
+        <p:cNvPr id="1" name=""/>
+        <p:cNvGrpSpPr/>
+        <p:nvPr/>
+      </p:nvGrpSpPr>
+      <p:grpSpPr>
+        <a:xfrm>
+          <a:off x="0" y="0"/>
+          <a:ext cx="0" cy="0"/>
+          <a:chOff x="0" y="0"/>
+          <a:chExt cx="0" cy="0"/>
+        </a:xfrm>
+      </p:grpSpPr>
+      <p:sp>
+        <p:nvSpPr>
+          <p:cNvPr id="2" name="Text 0"/>
+          <p:cNvSpPr/>
+          <p:nvPr/>
+        </p:nvSpPr>
+        <p:spPr>
+          <a:xfrm>
+            <a:off x="640080" y="365760"/>
+            <a:ext cx="10012680" cy="237744"/>
+          </a:xfrm>
+          <a:prstGeom prst="rect">
+            <a:avLst/>
+          </a:prstGeom>
+          <a:noFill/>
+          <a:ln/>
+        </p:spPr>
+        <p:txBody>
+          <a:bodyPr wrap="square" lIns="0" tIns="0" rIns="0" bIns="0" rtlCol="0" anchor="ctr"/>
+          <a:lstStyle/>
+          <a:p>
+            <a:pPr indent="0" marL="0">
+              <a:buNone/>
+            </a:pPr>
+            <a:r>
+              <a:rPr lang="en-US" sz="1100" b="1" spc="300" kern="0" dirty="0">
+                <a:solidFill>
+                  <a:srgbClr val="C8102E"/>
+                </a:solidFill>
+                <a:latin typeface="Calibri" pitchFamily="34" charset="0"/>
+                <a:ea typeface="Calibri" pitchFamily="34" charset="-122"/>
+                <a:cs typeface="Calibri" pitchFamily="34" charset="-120"/>
+              </a:rPr>
+              <a:t>05 · RELEASES</a:t>
+            </a:r>
+            <a:endParaRPr lang="en-US" sz="1100" dirty="0"/>
+          </a:p>
+        </p:txBody>
+      </p:sp>
+      <p:sp>
+        <p:nvSpPr>
+          <p:cNvPr id="3" name="Text 1"/>
+          <p:cNvSpPr/>
+          <p:nvPr/>
+        </p:nvSpPr>
+        <p:spPr>
+          <a:xfrm>
+            <a:off x="640080" y="603504"/>
+            <a:ext cx="10012680" cy="603504"/>
+          </a:xfrm>
+          <a:prstGeom prst="rect">
+            <a:avLst/>
+          </a:prstGeom>
+          <a:noFill/>
+          <a:ln/>
+        </p:spPr>
+        <p:txBody>
+          <a:bodyPr wrap="square" lIns="0" tIns="0" rIns="0" bIns="0" rtlCol="0" anchor="ctr"/>
+          <a:lstStyle/>
+          <a:p>
+            <a:pPr indent="0" marL="0">
+              <a:buNone/>
+            </a:pPr>
+            <a:r>
+              <a:rPr lang="en-US" sz="2900" b="1" dirty="0">
+                <a:solidFill>
+                  <a:srgbClr val="0F172A"/>
+                </a:solidFill>
+                <a:latin typeface="Trebuchet MS" pitchFamily="34" charset="0"/>
+                <a:ea typeface="Trebuchet MS" pitchFamily="34" charset="-122"/>
+                <a:cs typeface="Trebuchet MS" pitchFamily="34" charset="-120"/>
+              </a:rPr>
+              <a:t>Releases, hotfix y un push rechazado</a:t>
+            </a:r>
+            <a:endParaRPr lang="en-US" sz="2900" dirty="0"/>
+          </a:p>
+        </p:txBody>
+      </p:sp>
+      <p:sp>
+        <p:nvSpPr>
+          <p:cNvPr id="4" name="Shape 2"/>
+          <p:cNvSpPr/>
+          <p:nvPr/>
+        </p:nvSpPr>
+        <p:spPr>
+          <a:xfrm>
+            <a:off x="10972800" y="384048"/>
+            <a:ext cx="548640" cy="548640"/>
+          </a:xfrm>
+          <a:prstGeom prst="rect">
+            <a:avLst/>
+          </a:prstGeom>
+          <a:solidFill>
+            <a:srgbClr val="C8102E"/>
+          </a:solidFill>
+          <a:ln/>
+        </p:spPr>
+      </p:sp>
+      <p:sp>
+        <p:nvSpPr>
+          <p:cNvPr id="5" name="Text 3"/>
+          <p:cNvSpPr/>
+          <p:nvPr/>
+        </p:nvSpPr>
+        <p:spPr>
+          <a:xfrm>
+            <a:off x="10972800" y="384048"/>
+            <a:ext cx="548640" cy="548640"/>
+          </a:xfrm>
+          <a:prstGeom prst="rect">
+            <a:avLst/>
+          </a:prstGeom>
+          <a:noFill/>
+          <a:ln/>
+        </p:spPr>
+        <p:txBody>
+          <a:bodyPr wrap="square" lIns="0" tIns="0" rIns="0" bIns="0" rtlCol="0" anchor="ctr"/>
+          <a:lstStyle/>
+          <a:p>
+            <a:pPr algn="ctr" indent="0" marL="0">
+              <a:buNone/>
+            </a:pPr>
+            <a:r>
+              <a:rPr lang="en-US" sz="1600" b="1" dirty="0">
+                <a:solidFill>
+                  <a:srgbClr val="FFFFFF"/>
+                </a:solidFill>
+                <a:latin typeface="Trebuchet MS" pitchFamily="34" charset="0"/>
+                <a:ea typeface="Trebuchet MS" pitchFamily="34" charset="-122"/>
+                <a:cs typeface="Trebuchet MS" pitchFamily="34" charset="-120"/>
+              </a:rPr>
+              <a:t>15</a:t>
+            </a:r>
+            <a:endParaRPr lang="en-US" sz="1600" dirty="0"/>
+          </a:p>
+        </p:txBody>
+      </p:sp>
+      <p:sp>
+        <p:nvSpPr>
+          <p:cNvPr id="6" name="Shape 4"/>
+          <p:cNvSpPr/>
+          <p:nvPr/>
+        </p:nvSpPr>
+        <p:spPr>
+          <a:xfrm>
+            <a:off x="640080" y="1389888"/>
             <a:ext cx="2514600" cy="1572768"/>
           </a:xfrm>
           <a:prstGeom prst="rect">
@@ -8397,33 +8780,33 @@
       </p:sp>
       <p:sp>
         <p:nvSpPr>
-          <p:cNvPr id="25" name="Shape 23"/>
-          <p:cNvSpPr/>
-          <p:nvPr/>
-        </p:nvSpPr>
-        <p:spPr>
-          <a:xfrm>
-            <a:off x="9006840" y="1389888"/>
+          <p:cNvPr id="7" name="Shape 5"/>
+          <p:cNvSpPr/>
+          <p:nvPr/>
+        </p:nvSpPr>
+        <p:spPr>
+          <a:xfrm>
+            <a:off x="640080" y="1389888"/>
             <a:ext cx="68580" cy="1572768"/>
           </a:xfrm>
           <a:prstGeom prst="rect">
             <a:avLst/>
           </a:prstGeom>
           <a:solidFill>
-            <a:srgbClr val="2E9E6B"/>
+            <a:srgbClr val="C8102E"/>
           </a:solidFill>
           <a:ln/>
         </p:spPr>
       </p:sp>
       <p:sp>
         <p:nvSpPr>
-          <p:cNvPr id="26" name="Text 24"/>
-          <p:cNvSpPr/>
-          <p:nvPr/>
-        </p:nvSpPr>
-        <p:spPr>
-          <a:xfrm>
-            <a:off x="9208008" y="1481328"/>
+          <p:cNvPr id="8" name="Text 6"/>
+          <p:cNvSpPr/>
+          <p:nvPr/>
+        </p:nvSpPr>
+        <p:spPr>
+          <a:xfrm>
+            <a:off x="841248" y="1481328"/>
             <a:ext cx="2194560" cy="347472"/>
           </a:xfrm>
           <a:prstGeom prst="rect">
@@ -8442,13 +8825,13 @@
             <a:r>
               <a:rPr lang="en-US" sz="1600" b="1" dirty="0">
                 <a:solidFill>
-                  <a:srgbClr val="2E9E6B"/>
+                  <a:srgbClr val="C8102E"/>
                 </a:solidFill>
                 <a:latin typeface="Consolas" pitchFamily="34" charset="0"/>
                 <a:ea typeface="Consolas" pitchFamily="34" charset="-122"/>
                 <a:cs typeface="Consolas" pitchFamily="34" charset="-120"/>
               </a:rPr>
-              <a:t>v1.0.1</a:t>
+              <a:t>v1.0.0</a:t>
             </a:r>
             <a:endParaRPr lang="en-US" sz="1600" dirty="0"/>
           </a:p>
@@ -8456,13 +8839,13 @@
       </p:sp>
       <p:sp>
         <p:nvSpPr>
-          <p:cNvPr id="27" name="Text 25"/>
-          <p:cNvSpPr/>
-          <p:nvPr/>
-        </p:nvSpPr>
-        <p:spPr>
-          <a:xfrm>
-            <a:off x="9208008" y="1847088"/>
+          <p:cNvPr id="9" name="Text 7"/>
+          <p:cNvSpPr/>
+          <p:nvPr/>
+        </p:nvSpPr>
+        <p:spPr>
+          <a:xfrm>
+            <a:off x="841248" y="1847088"/>
             <a:ext cx="2194560" cy="237744"/>
           </a:xfrm>
           <a:prstGeom prst="rect">
@@ -8487,7 +8870,7 @@
                 <a:ea typeface="Trebuchet MS" pitchFamily="34" charset="-122"/>
                 <a:cs typeface="Trebuchet MS" pitchFamily="34" charset="-120"/>
               </a:rPr>
-              <a:t>Segundo release</a:t>
+              <a:t>Primer release</a:t>
             </a:r>
             <a:endParaRPr lang="en-US" sz="1150" dirty="0"/>
           </a:p>
@@ -8495,13 +8878,13 @@
       </p:sp>
       <p:sp>
         <p:nvSpPr>
-          <p:cNvPr id="28" name="Text 26"/>
-          <p:cNvSpPr/>
-          <p:nvPr/>
-        </p:nvSpPr>
-        <p:spPr>
-          <a:xfrm>
-            <a:off x="9208008" y="2121408"/>
+          <p:cNvPr id="10" name="Text 8"/>
+          <p:cNvSpPr/>
+          <p:nvPr/>
+        </p:nvSpPr>
+        <p:spPr>
+          <a:xfrm>
+            <a:off x="841248" y="2121408"/>
             <a:ext cx="2194560" cy="731520"/>
           </a:xfrm>
           <a:prstGeom prst="rect">
@@ -8526,7 +8909,7 @@
                 <a:ea typeface="Calibri" pitchFamily="34" charset="-122"/>
                 <a:cs typeface="Calibri" pitchFamily="34" charset="-120"/>
               </a:rPr>
-              <a:t>Corrección publicada y propagada a develop</a:t>
+              <a:t>Los 4 módulos integrados y etiquetados en main</a:t>
             </a:r>
             <a:endParaRPr lang="en-US" sz="1050" dirty="0"/>
           </a:p>
@@ -8534,306 +8917,38 @@
       </p:sp>
       <p:sp>
         <p:nvSpPr>
-          <p:cNvPr id="29" name="Text 27"/>
-          <p:cNvSpPr/>
-          <p:nvPr/>
-        </p:nvSpPr>
-        <p:spPr>
-          <a:xfrm>
-            <a:off x="640080" y="3310128"/>
-            <a:ext cx="5303520" cy="274320"/>
-          </a:xfrm>
-          <a:prstGeom prst="rect">
-            <a:avLst/>
-          </a:prstGeom>
-          <a:noFill/>
-          <a:ln/>
-        </p:spPr>
-        <p:txBody>
-          <a:bodyPr wrap="square" lIns="0" tIns="0" rIns="0" bIns="0" rtlCol="0" anchor="ctr"/>
-          <a:lstStyle/>
-          <a:p>
-            <a:pPr indent="0" marL="0">
-              <a:buNone/>
-            </a:pPr>
-            <a:r>
-              <a:rPr lang="en-US" sz="1350" b="1" dirty="0">
-                <a:solidFill>
-                  <a:srgbClr val="0F172A"/>
-                </a:solidFill>
-                <a:latin typeface="Trebuchet MS" pitchFamily="34" charset="0"/>
-                <a:ea typeface="Trebuchet MS" pitchFamily="34" charset="-122"/>
-                <a:cs typeface="Trebuchet MS" pitchFamily="34" charset="-120"/>
-              </a:rPr>
-              <a:t>Cuando el remoto avanzó sin nosotros</a:t>
-            </a:r>
-            <a:endParaRPr lang="en-US" sz="1350" dirty="0"/>
-          </a:p>
-        </p:txBody>
-      </p:sp>
-      <p:sp>
-        <p:nvSpPr>
-          <p:cNvPr id="30" name="Shape 28"/>
-          <p:cNvSpPr/>
-          <p:nvPr/>
-        </p:nvSpPr>
-        <p:spPr>
-          <a:xfrm>
-            <a:off x="640080" y="3639312"/>
-            <a:ext cx="5303520" cy="884682"/>
-          </a:xfrm>
-          <a:prstGeom prst="rect">
-            <a:avLst/>
-          </a:prstGeom>
-          <a:solidFill>
-            <a:srgbClr val="3A1A1E"/>
-          </a:solidFill>
-          <a:ln w="12700">
+          <p:cNvPr id="11" name="Shape 9"/>
+          <p:cNvSpPr/>
+          <p:nvPr/>
+        </p:nvSpPr>
+        <p:spPr>
+          <a:xfrm>
+            <a:off x="3218688" y="2176272"/>
+            <a:ext cx="155448" cy="0"/>
+          </a:xfrm>
+          <a:prstGeom prst="line">
+            <a:avLst/>
+          </a:prstGeom>
+          <a:noFill/>
+          <a:ln w="25400">
             <a:solidFill>
-              <a:srgbClr val="6B2B33"/>
+              <a:srgbClr val="8A97A6"/>
             </a:solidFill>
             <a:prstDash val="solid"/>
+            <a:tailEnd type="triangle"/>
           </a:ln>
         </p:spPr>
       </p:sp>
       <p:sp>
         <p:nvSpPr>
-          <p:cNvPr id="31" name="Text 29"/>
-          <p:cNvSpPr/>
-          <p:nvPr/>
-        </p:nvSpPr>
-        <p:spPr>
-          <a:xfrm>
-            <a:off x="786384" y="3758184"/>
-            <a:ext cx="5010912" cy="646938"/>
-          </a:xfrm>
-          <a:prstGeom prst="rect">
-            <a:avLst/>
-          </a:prstGeom>
-          <a:noFill/>
-          <a:ln/>
-        </p:spPr>
-        <p:txBody>
-          <a:bodyPr wrap="square" lIns="0" tIns="0" rIns="0" bIns="0" rtlCol="0" anchor="t"/>
-          <a:lstStyle/>
-          <a:p>
-            <a:pPr indent="0" marL="0">
-              <a:lnSpc>
-                <a:spcPts val="1650"/>
-              </a:lnSpc>
-              <a:buNone/>
-            </a:pPr>
-            <a:r>
-              <a:rPr lang="en-US" sz="1100" dirty="0">
-                <a:solidFill>
-                  <a:srgbClr val="DCE7F2"/>
-                </a:solidFill>
-                <a:latin typeface="Consolas" pitchFamily="34" charset="0"/>
-                <a:ea typeface="Consolas" pitchFamily="34" charset="-122"/>
-                <a:cs typeface="Consolas" pitchFamily="34" charset="-120"/>
-              </a:rPr>
-              <a:t>$ git push origin main</a:t>
-            </a:r>
-            <a:endParaRPr lang="en-US" sz="1100" dirty="0"/>
-          </a:p>
-          <a:p>
-            <a:pPr indent="0" marL="0">
-              <a:lnSpc>
-                <a:spcPts val="1650"/>
-              </a:lnSpc>
-              <a:buNone/>
-            </a:pPr>
-            <a:r>
-              <a:rPr lang="en-US" sz="1100" b="1" dirty="0">
-                <a:solidFill>
-                  <a:srgbClr val="FF9C9C"/>
-                </a:solidFill>
-                <a:latin typeface="Consolas" pitchFamily="34" charset="0"/>
-                <a:ea typeface="Consolas" pitchFamily="34" charset="-122"/>
-                <a:cs typeface="Consolas" pitchFamily="34" charset="-120"/>
-              </a:rPr>
-              <a:t> ! [rejected]  main -&gt; main (fetch first)</a:t>
-            </a:r>
-            <a:endParaRPr lang="en-US" sz="1100" dirty="0"/>
-          </a:p>
-          <a:p>
-            <a:pPr indent="0" marL="0">
-              <a:lnSpc>
-                <a:spcPts val="1650"/>
-              </a:lnSpc>
-              <a:buNone/>
-            </a:pPr>
-            <a:r>
-              <a:rPr lang="en-US" sz="1100" dirty="0">
-                <a:solidFill>
-                  <a:srgbClr val="F3BEBE"/>
-                </a:solidFill>
-                <a:latin typeface="Consolas" pitchFamily="34" charset="0"/>
-                <a:ea typeface="Consolas" pitchFamily="34" charset="-122"/>
-                <a:cs typeface="Consolas" pitchFamily="34" charset="-120"/>
-              </a:rPr>
-              <a:t>error: failed to push some refs</a:t>
-            </a:r>
-            <a:endParaRPr lang="en-US" sz="1100" dirty="0"/>
-          </a:p>
-        </p:txBody>
-      </p:sp>
-      <p:sp>
-        <p:nvSpPr>
-          <p:cNvPr id="32" name="Shape 30"/>
-          <p:cNvSpPr/>
-          <p:nvPr/>
-        </p:nvSpPr>
-        <p:spPr>
-          <a:xfrm>
-            <a:off x="640080" y="4798314"/>
-            <a:ext cx="5303520" cy="884682"/>
-          </a:xfrm>
-          <a:prstGeom prst="rect">
-            <a:avLst/>
-          </a:prstGeom>
-          <a:solidFill>
-            <a:srgbClr val="10301F"/>
-          </a:solidFill>
-          <a:ln w="12700">
-            <a:solidFill>
-              <a:srgbClr val="255239"/>
-            </a:solidFill>
-            <a:prstDash val="solid"/>
-          </a:ln>
-        </p:spPr>
-      </p:sp>
-      <p:sp>
-        <p:nvSpPr>
-          <p:cNvPr id="33" name="Text 31"/>
-          <p:cNvSpPr/>
-          <p:nvPr/>
-        </p:nvSpPr>
-        <p:spPr>
-          <a:xfrm>
-            <a:off x="786384" y="4917186"/>
-            <a:ext cx="5010912" cy="646938"/>
-          </a:xfrm>
-          <a:prstGeom prst="rect">
-            <a:avLst/>
-          </a:prstGeom>
-          <a:noFill/>
-          <a:ln/>
-        </p:spPr>
-        <p:txBody>
-          <a:bodyPr wrap="square" lIns="0" tIns="0" rIns="0" bIns="0" rtlCol="0" anchor="t"/>
-          <a:lstStyle/>
-          <a:p>
-            <a:pPr indent="0" marL="0">
-              <a:lnSpc>
-                <a:spcPts val="1650"/>
-              </a:lnSpc>
-              <a:buNone/>
-            </a:pPr>
-            <a:r>
-              <a:rPr lang="en-US" sz="1100" dirty="0">
-                <a:solidFill>
-                  <a:srgbClr val="9DEBBE"/>
-                </a:solidFill>
-                <a:latin typeface="Consolas" pitchFamily="34" charset="0"/>
-                <a:ea typeface="Consolas" pitchFamily="34" charset="-122"/>
-                <a:cs typeface="Consolas" pitchFamily="34" charset="-120"/>
-              </a:rPr>
-              <a:t>$ git fetch origin</a:t>
-            </a:r>
-            <a:endParaRPr lang="en-US" sz="1100" dirty="0"/>
-          </a:p>
-          <a:p>
-            <a:pPr indent="0" marL="0">
-              <a:lnSpc>
-                <a:spcPts val="1650"/>
-              </a:lnSpc>
-              <a:buNone/>
-            </a:pPr>
-            <a:r>
-              <a:rPr lang="en-US" sz="1100" dirty="0">
-                <a:solidFill>
-                  <a:srgbClr val="9DEBBE"/>
-                </a:solidFill>
-                <a:latin typeface="Consolas" pitchFamily="34" charset="0"/>
-                <a:ea typeface="Consolas" pitchFamily="34" charset="-122"/>
-                <a:cs typeface="Consolas" pitchFamily="34" charset="-120"/>
-              </a:rPr>
-              <a:t>$ git log --oneline HEAD..origin/main</a:t>
-            </a:r>
-            <a:endParaRPr lang="en-US" sz="1100" dirty="0"/>
-          </a:p>
-          <a:p>
-            <a:pPr indent="0" marL="0">
-              <a:lnSpc>
-                <a:spcPts val="1650"/>
-              </a:lnSpc>
-              <a:buNone/>
-            </a:pPr>
-            <a:r>
-              <a:rPr lang="en-US" sz="1100" b="1" dirty="0">
-                <a:solidFill>
-                  <a:srgbClr val="9DEBBE"/>
-                </a:solidFill>
-                <a:latin typeface="Consolas" pitchFamily="34" charset="0"/>
-                <a:ea typeface="Consolas" pitchFamily="34" charset="-122"/>
-                <a:cs typeface="Consolas" pitchFamily="34" charset="-120"/>
-              </a:rPr>
-              <a:t>$ git merge --no-ff origin/main</a:t>
-            </a:r>
-            <a:endParaRPr lang="en-US" sz="1100" dirty="0"/>
-          </a:p>
-        </p:txBody>
-      </p:sp>
-      <p:sp>
-        <p:nvSpPr>
-          <p:cNvPr id="34" name="Text 32"/>
-          <p:cNvSpPr/>
-          <p:nvPr/>
-        </p:nvSpPr>
-        <p:spPr>
-          <a:xfrm>
-            <a:off x="6217920" y="3310128"/>
-            <a:ext cx="5303520" cy="274320"/>
-          </a:xfrm>
-          <a:prstGeom prst="rect">
-            <a:avLst/>
-          </a:prstGeom>
-          <a:noFill/>
-          <a:ln/>
-        </p:spPr>
-        <p:txBody>
-          <a:bodyPr wrap="square" lIns="0" tIns="0" rIns="0" bIns="0" rtlCol="0" anchor="ctr"/>
-          <a:lstStyle/>
-          <a:p>
-            <a:pPr indent="0" marL="0">
-              <a:buNone/>
-            </a:pPr>
-            <a:r>
-              <a:rPr lang="en-US" sz="1350" b="1" dirty="0">
-                <a:solidFill>
-                  <a:srgbClr val="0F172A"/>
-                </a:solidFill>
-                <a:latin typeface="Trebuchet MS" pitchFamily="34" charset="0"/>
-                <a:ea typeface="Trebuchet MS" pitchFamily="34" charset="-122"/>
-                <a:cs typeface="Trebuchet MS" pitchFamily="34" charset="-120"/>
-              </a:rPr>
-              <a:t>La tentación era --force</a:t>
-            </a:r>
-            <a:endParaRPr lang="en-US" sz="1350" dirty="0"/>
-          </a:p>
-        </p:txBody>
-      </p:sp>
-      <p:sp>
-        <p:nvSpPr>
-          <p:cNvPr id="35" name="Shape 33"/>
-          <p:cNvSpPr/>
-          <p:nvPr/>
-        </p:nvSpPr>
-        <p:spPr>
-          <a:xfrm>
-            <a:off x="6217920" y="3639312"/>
-            <a:ext cx="5303520" cy="1993392"/>
+          <p:cNvPr id="12" name="Shape 10"/>
+          <p:cNvSpPr/>
+          <p:nvPr/>
+        </p:nvSpPr>
+        <p:spPr>
+          <a:xfrm>
+            <a:off x="3429000" y="1389888"/>
+            <a:ext cx="2514600" cy="1572768"/>
           </a:xfrm>
           <a:prstGeom prst="rect">
             <a:avLst/>
@@ -8858,6 +8973,853 @@
       </p:sp>
       <p:sp>
         <p:nvSpPr>
+          <p:cNvPr id="13" name="Shape 11"/>
+          <p:cNvSpPr/>
+          <p:nvPr/>
+        </p:nvSpPr>
+        <p:spPr>
+          <a:xfrm>
+            <a:off x="3429000" y="1389888"/>
+            <a:ext cx="68580" cy="1572768"/>
+          </a:xfrm>
+          <a:prstGeom prst="rect">
+            <a:avLst/>
+          </a:prstGeom>
+          <a:solidFill>
+            <a:srgbClr val="D97706"/>
+          </a:solidFill>
+          <a:ln/>
+        </p:spPr>
+      </p:sp>
+      <p:sp>
+        <p:nvSpPr>
+          <p:cNvPr id="14" name="Text 12"/>
+          <p:cNvSpPr/>
+          <p:nvPr/>
+        </p:nvSpPr>
+        <p:spPr>
+          <a:xfrm>
+            <a:off x="3630168" y="1481328"/>
+            <a:ext cx="2194560" cy="347472"/>
+          </a:xfrm>
+          <a:prstGeom prst="rect">
+            <a:avLst/>
+          </a:prstGeom>
+          <a:noFill/>
+          <a:ln/>
+        </p:spPr>
+        <p:txBody>
+          <a:bodyPr wrap="square" lIns="0" tIns="0" rIns="0" bIns="0" rtlCol="0" anchor="ctr"/>
+          <a:lstStyle/>
+          <a:p>
+            <a:pPr indent="0" marL="0">
+              <a:buNone/>
+            </a:pPr>
+            <a:r>
+              <a:rPr lang="en-US" sz="1600" b="1" dirty="0">
+                <a:solidFill>
+                  <a:srgbClr val="D97706"/>
+                </a:solidFill>
+                <a:latin typeface="Consolas" pitchFamily="34" charset="0"/>
+                <a:ea typeface="Consolas" pitchFamily="34" charset="-122"/>
+                <a:cs typeface="Consolas" pitchFamily="34" charset="-120"/>
+              </a:rPr>
+              <a:t>Bug</a:t>
+            </a:r>
+            <a:endParaRPr lang="en-US" sz="1600" dirty="0"/>
+          </a:p>
+        </p:txBody>
+      </p:sp>
+      <p:sp>
+        <p:nvSpPr>
+          <p:cNvPr id="15" name="Text 13"/>
+          <p:cNvSpPr/>
+          <p:nvPr/>
+        </p:nvSpPr>
+        <p:spPr>
+          <a:xfrm>
+            <a:off x="3630168" y="1847088"/>
+            <a:ext cx="2194560" cy="237744"/>
+          </a:xfrm>
+          <a:prstGeom prst="rect">
+            <a:avLst/>
+          </a:prstGeom>
+          <a:noFill/>
+          <a:ln/>
+        </p:spPr>
+        <p:txBody>
+          <a:bodyPr wrap="square" lIns="0" tIns="0" rIns="0" bIns="0" rtlCol="0" anchor="ctr"/>
+          <a:lstStyle/>
+          <a:p>
+            <a:pPr indent="0" marL="0">
+              <a:buNone/>
+            </a:pPr>
+            <a:r>
+              <a:rPr lang="en-US" sz="1150" b="1" dirty="0">
+                <a:solidFill>
+                  <a:srgbClr val="0F172A"/>
+                </a:solidFill>
+                <a:latin typeface="Trebuchet MS" pitchFamily="34" charset="0"/>
+                <a:ea typeface="Trebuchet MS" pitchFamily="34" charset="-122"/>
+                <a:cs typeface="Trebuchet MS" pitchFamily="34" charset="-120"/>
+              </a:rPr>
+              <a:t>Detectado en pruebas</a:t>
+            </a:r>
+            <a:endParaRPr lang="en-US" sz="1150" dirty="0"/>
+          </a:p>
+        </p:txBody>
+      </p:sp>
+      <p:sp>
+        <p:nvSpPr>
+          <p:cNvPr id="16" name="Text 14"/>
+          <p:cNvSpPr/>
+          <p:nvPr/>
+        </p:nvSpPr>
+        <p:spPr>
+          <a:xfrm>
+            <a:off x="3630168" y="2121408"/>
+            <a:ext cx="2194560" cy="731520"/>
+          </a:xfrm>
+          <a:prstGeom prst="rect">
+            <a:avLst/>
+          </a:prstGeom>
+          <a:noFill/>
+          <a:ln/>
+        </p:spPr>
+        <p:txBody>
+          <a:bodyPr wrap="square" lIns="0" tIns="0" rIns="0" bIns="0" rtlCol="0" anchor="ctr"/>
+          <a:lstStyle/>
+          <a:p>
+            <a:pPr indent="0" marL="0">
+              <a:buNone/>
+            </a:pPr>
+            <a:r>
+              <a:rPr lang="en-US" sz="1050" dirty="0">
+                <a:solidFill>
+                  <a:srgbClr val="55606E"/>
+                </a:solidFill>
+                <a:latin typeface="Calibri" pitchFamily="34" charset="0"/>
+                <a:ea typeface="Calibri" pitchFamily="34" charset="-122"/>
+                <a:cs typeface="Calibri" pitchFamily="34" charset="-120"/>
+              </a:rPr>
+              <a:t>La API devolvía HTML en vez de JSON</a:t>
+            </a:r>
+            <a:endParaRPr lang="en-US" sz="1050" dirty="0"/>
+          </a:p>
+        </p:txBody>
+      </p:sp>
+      <p:sp>
+        <p:nvSpPr>
+          <p:cNvPr id="17" name="Shape 15"/>
+          <p:cNvSpPr/>
+          <p:nvPr/>
+        </p:nvSpPr>
+        <p:spPr>
+          <a:xfrm>
+            <a:off x="6007608" y="2176272"/>
+            <a:ext cx="155448" cy="0"/>
+          </a:xfrm>
+          <a:prstGeom prst="line">
+            <a:avLst/>
+          </a:prstGeom>
+          <a:noFill/>
+          <a:ln w="25400">
+            <a:solidFill>
+              <a:srgbClr val="8A97A6"/>
+            </a:solidFill>
+            <a:prstDash val="solid"/>
+            <a:tailEnd type="triangle"/>
+          </a:ln>
+        </p:spPr>
+      </p:sp>
+      <p:sp>
+        <p:nvSpPr>
+          <p:cNvPr id="18" name="Shape 16"/>
+          <p:cNvSpPr/>
+          <p:nvPr/>
+        </p:nvSpPr>
+        <p:spPr>
+          <a:xfrm>
+            <a:off x="6217920" y="1389888"/>
+            <a:ext cx="2514600" cy="1572768"/>
+          </a:xfrm>
+          <a:prstGeom prst="rect">
+            <a:avLst/>
+          </a:prstGeom>
+          <a:solidFill>
+            <a:srgbClr val="FFFFFF"/>
+          </a:solidFill>
+          <a:ln w="12700">
+            <a:solidFill>
+              <a:srgbClr val="D7DEE8"/>
+            </a:solidFill>
+            <a:prstDash val="solid"/>
+          </a:ln>
+          <a:effectLst>
+            <a:outerShdw sx="100000" sy="100000" kx="0" ky="0" algn="bl" rotWithShape="0" blurRad="127000" dist="25400" dir="5400000">
+              <a:srgbClr val="0B1B2B">
+                <a:alpha val="10000"/>
+              </a:srgbClr>
+            </a:outerShdw>
+          </a:effectLst>
+        </p:spPr>
+      </p:sp>
+      <p:sp>
+        <p:nvSpPr>
+          <p:cNvPr id="19" name="Shape 17"/>
+          <p:cNvSpPr/>
+          <p:nvPr/>
+        </p:nvSpPr>
+        <p:spPr>
+          <a:xfrm>
+            <a:off x="6217920" y="1389888"/>
+            <a:ext cx="68580" cy="1572768"/>
+          </a:xfrm>
+          <a:prstGeom prst="rect">
+            <a:avLst/>
+          </a:prstGeom>
+          <a:solidFill>
+            <a:srgbClr val="7C3AED"/>
+          </a:solidFill>
+          <a:ln/>
+        </p:spPr>
+      </p:sp>
+      <p:sp>
+        <p:nvSpPr>
+          <p:cNvPr id="20" name="Text 18"/>
+          <p:cNvSpPr/>
+          <p:nvPr/>
+        </p:nvSpPr>
+        <p:spPr>
+          <a:xfrm>
+            <a:off x="6419088" y="1481328"/>
+            <a:ext cx="2194560" cy="347472"/>
+          </a:xfrm>
+          <a:prstGeom prst="rect">
+            <a:avLst/>
+          </a:prstGeom>
+          <a:noFill/>
+          <a:ln/>
+        </p:spPr>
+        <p:txBody>
+          <a:bodyPr wrap="square" lIns="0" tIns="0" rIns="0" bIns="0" rtlCol="0" anchor="ctr"/>
+          <a:lstStyle/>
+          <a:p>
+            <a:pPr indent="0" marL="0">
+              <a:buNone/>
+            </a:pPr>
+            <a:r>
+              <a:rPr lang="en-US" sz="1600" b="1" dirty="0">
+                <a:solidFill>
+                  <a:srgbClr val="7C3AED"/>
+                </a:solidFill>
+                <a:latin typeface="Consolas" pitchFamily="34" charset="0"/>
+                <a:ea typeface="Consolas" pitchFamily="34" charset="-122"/>
+                <a:cs typeface="Consolas" pitchFamily="34" charset="-120"/>
+              </a:rPr>
+              <a:t>hotfix</a:t>
+            </a:r>
+            <a:endParaRPr lang="en-US" sz="1600" dirty="0"/>
+          </a:p>
+        </p:txBody>
+      </p:sp>
+      <p:sp>
+        <p:nvSpPr>
+          <p:cNvPr id="21" name="Text 19"/>
+          <p:cNvSpPr/>
+          <p:nvPr/>
+        </p:nvSpPr>
+        <p:spPr>
+          <a:xfrm>
+            <a:off x="6419088" y="1847088"/>
+            <a:ext cx="2194560" cy="237744"/>
+          </a:xfrm>
+          <a:prstGeom prst="rect">
+            <a:avLst/>
+          </a:prstGeom>
+          <a:noFill/>
+          <a:ln/>
+        </p:spPr>
+        <p:txBody>
+          <a:bodyPr wrap="square" lIns="0" tIns="0" rIns="0" bIns="0" rtlCol="0" anchor="ctr"/>
+          <a:lstStyle/>
+          <a:p>
+            <a:pPr indent="0" marL="0">
+              <a:buNone/>
+            </a:pPr>
+            <a:r>
+              <a:rPr lang="en-US" sz="1150" b="1" dirty="0">
+                <a:solidFill>
+                  <a:srgbClr val="0F172A"/>
+                </a:solidFill>
+                <a:latin typeface="Trebuchet MS" pitchFamily="34" charset="0"/>
+                <a:ea typeface="Trebuchet MS" pitchFamily="34" charset="-122"/>
+                <a:cs typeface="Trebuchet MS" pitchFamily="34" charset="-120"/>
+              </a:rPr>
+              <a:t>Rama desde main</a:t>
+            </a:r>
+            <a:endParaRPr lang="en-US" sz="1150" dirty="0"/>
+          </a:p>
+        </p:txBody>
+      </p:sp>
+      <p:sp>
+        <p:nvSpPr>
+          <p:cNvPr id="22" name="Text 20"/>
+          <p:cNvSpPr/>
+          <p:nvPr/>
+        </p:nvSpPr>
+        <p:spPr>
+          <a:xfrm>
+            <a:off x="6419088" y="2121408"/>
+            <a:ext cx="2194560" cy="731520"/>
+          </a:xfrm>
+          <a:prstGeom prst="rect">
+            <a:avLst/>
+          </a:prstGeom>
+          <a:noFill/>
+          <a:ln/>
+        </p:spPr>
+        <p:txBody>
+          <a:bodyPr wrap="square" lIns="0" tIns="0" rIns="0" bIns="0" rtlCol="0" anchor="ctr"/>
+          <a:lstStyle/>
+          <a:p>
+            <a:pPr indent="0" marL="0">
+              <a:buNone/>
+            </a:pPr>
+            <a:r>
+              <a:rPr lang="en-US" sz="1050" dirty="0">
+                <a:solidFill>
+                  <a:srgbClr val="55606E"/>
+                </a:solidFill>
+                <a:latin typeface="Calibri" pitchFamily="34" charset="0"/>
+                <a:ea typeface="Calibri" pitchFamily="34" charset="-122"/>
+                <a:cs typeface="Calibri" pitchFamily="34" charset="-120"/>
+              </a:rPr>
+              <a:t>Corrección aislada, sin arrastrar develop</a:t>
+            </a:r>
+            <a:endParaRPr lang="en-US" sz="1050" dirty="0"/>
+          </a:p>
+        </p:txBody>
+      </p:sp>
+      <p:sp>
+        <p:nvSpPr>
+          <p:cNvPr id="23" name="Shape 21"/>
+          <p:cNvSpPr/>
+          <p:nvPr/>
+        </p:nvSpPr>
+        <p:spPr>
+          <a:xfrm>
+            <a:off x="8796528" y="2176272"/>
+            <a:ext cx="155448" cy="0"/>
+          </a:xfrm>
+          <a:prstGeom prst="line">
+            <a:avLst/>
+          </a:prstGeom>
+          <a:noFill/>
+          <a:ln w="25400">
+            <a:solidFill>
+              <a:srgbClr val="8A97A6"/>
+            </a:solidFill>
+            <a:prstDash val="solid"/>
+            <a:tailEnd type="triangle"/>
+          </a:ln>
+        </p:spPr>
+      </p:sp>
+      <p:sp>
+        <p:nvSpPr>
+          <p:cNvPr id="24" name="Shape 22"/>
+          <p:cNvSpPr/>
+          <p:nvPr/>
+        </p:nvSpPr>
+        <p:spPr>
+          <a:xfrm>
+            <a:off x="9006840" y="1389888"/>
+            <a:ext cx="2514600" cy="1572768"/>
+          </a:xfrm>
+          <a:prstGeom prst="rect">
+            <a:avLst/>
+          </a:prstGeom>
+          <a:solidFill>
+            <a:srgbClr val="FFFFFF"/>
+          </a:solidFill>
+          <a:ln w="12700">
+            <a:solidFill>
+              <a:srgbClr val="D7DEE8"/>
+            </a:solidFill>
+            <a:prstDash val="solid"/>
+          </a:ln>
+          <a:effectLst>
+            <a:outerShdw sx="100000" sy="100000" kx="0" ky="0" algn="bl" rotWithShape="0" blurRad="127000" dist="25400" dir="5400000">
+              <a:srgbClr val="0B1B2B">
+                <a:alpha val="10000"/>
+              </a:srgbClr>
+            </a:outerShdw>
+          </a:effectLst>
+        </p:spPr>
+      </p:sp>
+      <p:sp>
+        <p:nvSpPr>
+          <p:cNvPr id="25" name="Shape 23"/>
+          <p:cNvSpPr/>
+          <p:nvPr/>
+        </p:nvSpPr>
+        <p:spPr>
+          <a:xfrm>
+            <a:off x="9006840" y="1389888"/>
+            <a:ext cx="68580" cy="1572768"/>
+          </a:xfrm>
+          <a:prstGeom prst="rect">
+            <a:avLst/>
+          </a:prstGeom>
+          <a:solidFill>
+            <a:srgbClr val="2E9E6B"/>
+          </a:solidFill>
+          <a:ln/>
+        </p:spPr>
+      </p:sp>
+      <p:sp>
+        <p:nvSpPr>
+          <p:cNvPr id="26" name="Text 24"/>
+          <p:cNvSpPr/>
+          <p:nvPr/>
+        </p:nvSpPr>
+        <p:spPr>
+          <a:xfrm>
+            <a:off x="9208008" y="1481328"/>
+            <a:ext cx="2194560" cy="347472"/>
+          </a:xfrm>
+          <a:prstGeom prst="rect">
+            <a:avLst/>
+          </a:prstGeom>
+          <a:noFill/>
+          <a:ln/>
+        </p:spPr>
+        <p:txBody>
+          <a:bodyPr wrap="square" lIns="0" tIns="0" rIns="0" bIns="0" rtlCol="0" anchor="ctr"/>
+          <a:lstStyle/>
+          <a:p>
+            <a:pPr indent="0" marL="0">
+              <a:buNone/>
+            </a:pPr>
+            <a:r>
+              <a:rPr lang="en-US" sz="1600" b="1" dirty="0">
+                <a:solidFill>
+                  <a:srgbClr val="2E9E6B"/>
+                </a:solidFill>
+                <a:latin typeface="Consolas" pitchFamily="34" charset="0"/>
+                <a:ea typeface="Consolas" pitchFamily="34" charset="-122"/>
+                <a:cs typeface="Consolas" pitchFamily="34" charset="-120"/>
+              </a:rPr>
+              <a:t>v1.0.1</a:t>
+            </a:r>
+            <a:endParaRPr lang="en-US" sz="1600" dirty="0"/>
+          </a:p>
+        </p:txBody>
+      </p:sp>
+      <p:sp>
+        <p:nvSpPr>
+          <p:cNvPr id="27" name="Text 25"/>
+          <p:cNvSpPr/>
+          <p:nvPr/>
+        </p:nvSpPr>
+        <p:spPr>
+          <a:xfrm>
+            <a:off x="9208008" y="1847088"/>
+            <a:ext cx="2194560" cy="237744"/>
+          </a:xfrm>
+          <a:prstGeom prst="rect">
+            <a:avLst/>
+          </a:prstGeom>
+          <a:noFill/>
+          <a:ln/>
+        </p:spPr>
+        <p:txBody>
+          <a:bodyPr wrap="square" lIns="0" tIns="0" rIns="0" bIns="0" rtlCol="0" anchor="ctr"/>
+          <a:lstStyle/>
+          <a:p>
+            <a:pPr indent="0" marL="0">
+              <a:buNone/>
+            </a:pPr>
+            <a:r>
+              <a:rPr lang="en-US" sz="1150" b="1" dirty="0">
+                <a:solidFill>
+                  <a:srgbClr val="0F172A"/>
+                </a:solidFill>
+                <a:latin typeface="Trebuchet MS" pitchFamily="34" charset="0"/>
+                <a:ea typeface="Trebuchet MS" pitchFamily="34" charset="-122"/>
+                <a:cs typeface="Trebuchet MS" pitchFamily="34" charset="-120"/>
+              </a:rPr>
+              <a:t>Segundo release</a:t>
+            </a:r>
+            <a:endParaRPr lang="en-US" sz="1150" dirty="0"/>
+          </a:p>
+        </p:txBody>
+      </p:sp>
+      <p:sp>
+        <p:nvSpPr>
+          <p:cNvPr id="28" name="Text 26"/>
+          <p:cNvSpPr/>
+          <p:nvPr/>
+        </p:nvSpPr>
+        <p:spPr>
+          <a:xfrm>
+            <a:off x="9208008" y="2121408"/>
+            <a:ext cx="2194560" cy="731520"/>
+          </a:xfrm>
+          <a:prstGeom prst="rect">
+            <a:avLst/>
+          </a:prstGeom>
+          <a:noFill/>
+          <a:ln/>
+        </p:spPr>
+        <p:txBody>
+          <a:bodyPr wrap="square" lIns="0" tIns="0" rIns="0" bIns="0" rtlCol="0" anchor="ctr"/>
+          <a:lstStyle/>
+          <a:p>
+            <a:pPr indent="0" marL="0">
+              <a:buNone/>
+            </a:pPr>
+            <a:r>
+              <a:rPr lang="en-US" sz="1050" dirty="0">
+                <a:solidFill>
+                  <a:srgbClr val="55606E"/>
+                </a:solidFill>
+                <a:latin typeface="Calibri" pitchFamily="34" charset="0"/>
+                <a:ea typeface="Calibri" pitchFamily="34" charset="-122"/>
+                <a:cs typeface="Calibri" pitchFamily="34" charset="-120"/>
+              </a:rPr>
+              <a:t>Corrección publicada y propagada a develop</a:t>
+            </a:r>
+            <a:endParaRPr lang="en-US" sz="1050" dirty="0"/>
+          </a:p>
+        </p:txBody>
+      </p:sp>
+      <p:sp>
+        <p:nvSpPr>
+          <p:cNvPr id="29" name="Text 27"/>
+          <p:cNvSpPr/>
+          <p:nvPr/>
+        </p:nvSpPr>
+        <p:spPr>
+          <a:xfrm>
+            <a:off x="640080" y="3310128"/>
+            <a:ext cx="5303520" cy="274320"/>
+          </a:xfrm>
+          <a:prstGeom prst="rect">
+            <a:avLst/>
+          </a:prstGeom>
+          <a:noFill/>
+          <a:ln/>
+        </p:spPr>
+        <p:txBody>
+          <a:bodyPr wrap="square" lIns="0" tIns="0" rIns="0" bIns="0" rtlCol="0" anchor="ctr"/>
+          <a:lstStyle/>
+          <a:p>
+            <a:pPr indent="0" marL="0">
+              <a:buNone/>
+            </a:pPr>
+            <a:r>
+              <a:rPr lang="en-US" sz="1350" b="1" dirty="0">
+                <a:solidFill>
+                  <a:srgbClr val="0F172A"/>
+                </a:solidFill>
+                <a:latin typeface="Trebuchet MS" pitchFamily="34" charset="0"/>
+                <a:ea typeface="Trebuchet MS" pitchFamily="34" charset="-122"/>
+                <a:cs typeface="Trebuchet MS" pitchFamily="34" charset="-120"/>
+              </a:rPr>
+              <a:t>Cuando el remoto avanzó sin nosotros</a:t>
+            </a:r>
+            <a:endParaRPr lang="en-US" sz="1350" dirty="0"/>
+          </a:p>
+        </p:txBody>
+      </p:sp>
+      <p:sp>
+        <p:nvSpPr>
+          <p:cNvPr id="30" name="Shape 28"/>
+          <p:cNvSpPr/>
+          <p:nvPr/>
+        </p:nvSpPr>
+        <p:spPr>
+          <a:xfrm>
+            <a:off x="640080" y="3639312"/>
+            <a:ext cx="5303520" cy="884682"/>
+          </a:xfrm>
+          <a:prstGeom prst="rect">
+            <a:avLst/>
+          </a:prstGeom>
+          <a:solidFill>
+            <a:srgbClr val="3A1A1E"/>
+          </a:solidFill>
+          <a:ln w="12700">
+            <a:solidFill>
+              <a:srgbClr val="6B2B33"/>
+            </a:solidFill>
+            <a:prstDash val="solid"/>
+          </a:ln>
+        </p:spPr>
+      </p:sp>
+      <p:sp>
+        <p:nvSpPr>
+          <p:cNvPr id="31" name="Text 29"/>
+          <p:cNvSpPr/>
+          <p:nvPr/>
+        </p:nvSpPr>
+        <p:spPr>
+          <a:xfrm>
+            <a:off x="786384" y="3758184"/>
+            <a:ext cx="5010912" cy="646938"/>
+          </a:xfrm>
+          <a:prstGeom prst="rect">
+            <a:avLst/>
+          </a:prstGeom>
+          <a:noFill/>
+          <a:ln/>
+        </p:spPr>
+        <p:txBody>
+          <a:bodyPr wrap="square" lIns="0" tIns="0" rIns="0" bIns="0" rtlCol="0" anchor="t"/>
+          <a:lstStyle/>
+          <a:p>
+            <a:pPr indent="0" marL="0">
+              <a:lnSpc>
+                <a:spcPts val="1650"/>
+              </a:lnSpc>
+              <a:buNone/>
+            </a:pPr>
+            <a:r>
+              <a:rPr lang="en-US" sz="1100" dirty="0">
+                <a:solidFill>
+                  <a:srgbClr val="DCE7F2"/>
+                </a:solidFill>
+                <a:latin typeface="Consolas" pitchFamily="34" charset="0"/>
+                <a:ea typeface="Consolas" pitchFamily="34" charset="-122"/>
+                <a:cs typeface="Consolas" pitchFamily="34" charset="-120"/>
+              </a:rPr>
+              <a:t>$ git push origin main</a:t>
+            </a:r>
+            <a:endParaRPr lang="en-US" sz="1100" dirty="0"/>
+          </a:p>
+          <a:p>
+            <a:pPr indent="0" marL="0">
+              <a:lnSpc>
+                <a:spcPts val="1650"/>
+              </a:lnSpc>
+              <a:buNone/>
+            </a:pPr>
+            <a:r>
+              <a:rPr lang="en-US" sz="1100" b="1" dirty="0">
+                <a:solidFill>
+                  <a:srgbClr val="FF9C9C"/>
+                </a:solidFill>
+                <a:latin typeface="Consolas" pitchFamily="34" charset="0"/>
+                <a:ea typeface="Consolas" pitchFamily="34" charset="-122"/>
+                <a:cs typeface="Consolas" pitchFamily="34" charset="-120"/>
+              </a:rPr>
+              <a:t> ! [rejected]  main -&gt; main (fetch first)</a:t>
+            </a:r>
+            <a:endParaRPr lang="en-US" sz="1100" dirty="0"/>
+          </a:p>
+          <a:p>
+            <a:pPr indent="0" marL="0">
+              <a:lnSpc>
+                <a:spcPts val="1650"/>
+              </a:lnSpc>
+              <a:buNone/>
+            </a:pPr>
+            <a:r>
+              <a:rPr lang="en-US" sz="1100" dirty="0">
+                <a:solidFill>
+                  <a:srgbClr val="F3BEBE"/>
+                </a:solidFill>
+                <a:latin typeface="Consolas" pitchFamily="34" charset="0"/>
+                <a:ea typeface="Consolas" pitchFamily="34" charset="-122"/>
+                <a:cs typeface="Consolas" pitchFamily="34" charset="-120"/>
+              </a:rPr>
+              <a:t>error: failed to push some refs</a:t>
+            </a:r>
+            <a:endParaRPr lang="en-US" sz="1100" dirty="0"/>
+          </a:p>
+        </p:txBody>
+      </p:sp>
+      <p:sp>
+        <p:nvSpPr>
+          <p:cNvPr id="32" name="Shape 30"/>
+          <p:cNvSpPr/>
+          <p:nvPr/>
+        </p:nvSpPr>
+        <p:spPr>
+          <a:xfrm>
+            <a:off x="640080" y="4798314"/>
+            <a:ext cx="5303520" cy="884682"/>
+          </a:xfrm>
+          <a:prstGeom prst="rect">
+            <a:avLst/>
+          </a:prstGeom>
+          <a:solidFill>
+            <a:srgbClr val="10301F"/>
+          </a:solidFill>
+          <a:ln w="12700">
+            <a:solidFill>
+              <a:srgbClr val="255239"/>
+            </a:solidFill>
+            <a:prstDash val="solid"/>
+          </a:ln>
+        </p:spPr>
+      </p:sp>
+      <p:sp>
+        <p:nvSpPr>
+          <p:cNvPr id="33" name="Text 31"/>
+          <p:cNvSpPr/>
+          <p:nvPr/>
+        </p:nvSpPr>
+        <p:spPr>
+          <a:xfrm>
+            <a:off x="786384" y="4917186"/>
+            <a:ext cx="5010912" cy="646938"/>
+          </a:xfrm>
+          <a:prstGeom prst="rect">
+            <a:avLst/>
+          </a:prstGeom>
+          <a:noFill/>
+          <a:ln/>
+        </p:spPr>
+        <p:txBody>
+          <a:bodyPr wrap="square" lIns="0" tIns="0" rIns="0" bIns="0" rtlCol="0" anchor="t"/>
+          <a:lstStyle/>
+          <a:p>
+            <a:pPr indent="0" marL="0">
+              <a:lnSpc>
+                <a:spcPts val="1650"/>
+              </a:lnSpc>
+              <a:buNone/>
+            </a:pPr>
+            <a:r>
+              <a:rPr lang="en-US" sz="1100" dirty="0">
+                <a:solidFill>
+                  <a:srgbClr val="9DEBBE"/>
+                </a:solidFill>
+                <a:latin typeface="Consolas" pitchFamily="34" charset="0"/>
+                <a:ea typeface="Consolas" pitchFamily="34" charset="-122"/>
+                <a:cs typeface="Consolas" pitchFamily="34" charset="-120"/>
+              </a:rPr>
+              <a:t>$ git fetch origin</a:t>
+            </a:r>
+            <a:endParaRPr lang="en-US" sz="1100" dirty="0"/>
+          </a:p>
+          <a:p>
+            <a:pPr indent="0" marL="0">
+              <a:lnSpc>
+                <a:spcPts val="1650"/>
+              </a:lnSpc>
+              <a:buNone/>
+            </a:pPr>
+            <a:r>
+              <a:rPr lang="en-US" sz="1100" dirty="0">
+                <a:solidFill>
+                  <a:srgbClr val="9DEBBE"/>
+                </a:solidFill>
+                <a:latin typeface="Consolas" pitchFamily="34" charset="0"/>
+                <a:ea typeface="Consolas" pitchFamily="34" charset="-122"/>
+                <a:cs typeface="Consolas" pitchFamily="34" charset="-120"/>
+              </a:rPr>
+              <a:t>$ git log --oneline HEAD..origin/main</a:t>
+            </a:r>
+            <a:endParaRPr lang="en-US" sz="1100" dirty="0"/>
+          </a:p>
+          <a:p>
+            <a:pPr indent="0" marL="0">
+              <a:lnSpc>
+                <a:spcPts val="1650"/>
+              </a:lnSpc>
+              <a:buNone/>
+            </a:pPr>
+            <a:r>
+              <a:rPr lang="en-US" sz="1100" b="1" dirty="0">
+                <a:solidFill>
+                  <a:srgbClr val="9DEBBE"/>
+                </a:solidFill>
+                <a:latin typeface="Consolas" pitchFamily="34" charset="0"/>
+                <a:ea typeface="Consolas" pitchFamily="34" charset="-122"/>
+                <a:cs typeface="Consolas" pitchFamily="34" charset="-120"/>
+              </a:rPr>
+              <a:t>$ git merge --no-ff origin/main</a:t>
+            </a:r>
+            <a:endParaRPr lang="en-US" sz="1100" dirty="0"/>
+          </a:p>
+        </p:txBody>
+      </p:sp>
+      <p:sp>
+        <p:nvSpPr>
+          <p:cNvPr id="34" name="Text 32"/>
+          <p:cNvSpPr/>
+          <p:nvPr/>
+        </p:nvSpPr>
+        <p:spPr>
+          <a:xfrm>
+            <a:off x="6217920" y="3310128"/>
+            <a:ext cx="5303520" cy="274320"/>
+          </a:xfrm>
+          <a:prstGeom prst="rect">
+            <a:avLst/>
+          </a:prstGeom>
+          <a:noFill/>
+          <a:ln/>
+        </p:spPr>
+        <p:txBody>
+          <a:bodyPr wrap="square" lIns="0" tIns="0" rIns="0" bIns="0" rtlCol="0" anchor="ctr"/>
+          <a:lstStyle/>
+          <a:p>
+            <a:pPr indent="0" marL="0">
+              <a:buNone/>
+            </a:pPr>
+            <a:r>
+              <a:rPr lang="en-US" sz="1350" b="1" dirty="0">
+                <a:solidFill>
+                  <a:srgbClr val="0F172A"/>
+                </a:solidFill>
+                <a:latin typeface="Trebuchet MS" pitchFamily="34" charset="0"/>
+                <a:ea typeface="Trebuchet MS" pitchFamily="34" charset="-122"/>
+                <a:cs typeface="Trebuchet MS" pitchFamily="34" charset="-120"/>
+              </a:rPr>
+              <a:t>La tentación era --force</a:t>
+            </a:r>
+            <a:endParaRPr lang="en-US" sz="1350" dirty="0"/>
+          </a:p>
+        </p:txBody>
+      </p:sp>
+      <p:sp>
+        <p:nvSpPr>
+          <p:cNvPr id="35" name="Shape 33"/>
+          <p:cNvSpPr/>
+          <p:nvPr/>
+        </p:nvSpPr>
+        <p:spPr>
+          <a:xfrm>
+            <a:off x="6217920" y="3639312"/>
+            <a:ext cx="5303520" cy="1993392"/>
+          </a:xfrm>
+          <a:prstGeom prst="rect">
+            <a:avLst/>
+          </a:prstGeom>
+          <a:solidFill>
+            <a:srgbClr val="FFFFFF"/>
+          </a:solidFill>
+          <a:ln w="12700">
+            <a:solidFill>
+              <a:srgbClr val="D7DEE8"/>
+            </a:solidFill>
+            <a:prstDash val="solid"/>
+          </a:ln>
+          <a:effectLst>
+            <a:outerShdw sx="100000" sy="100000" kx="0" ky="0" algn="bl" rotWithShape="0" blurRad="127000" dist="25400" dir="5400000">
+              <a:srgbClr val="0B1B2B">
+                <a:alpha val="10000"/>
+              </a:srgbClr>
+            </a:outerShdw>
+          </a:effectLst>
+        </p:spPr>
+      </p:sp>
+      <p:sp>
+        <p:nvSpPr>
           <p:cNvPr id="36" name="Shape 34"/>
           <p:cNvSpPr/>
           <p:nvPr/>
@@ -9008,9 +9970,9 @@
 </p:sld>
 </file>
 
-<file path=ppt/slides/slide15.xml><?xml version="1.0" encoding="utf-8"?>
+<file path=ppt/slides/slide16.xml><?xml version="1.0" encoding="utf-8"?>
 <p:sld xmlns:a="http://schemas.openxmlformats.org/drawingml/2006/main" xmlns:r="http://schemas.openxmlformats.org/officeDocument/2006/relationships" xmlns:p="http://schemas.openxmlformats.org/presentationml/2006/main">
-  <p:cSld name="Slide 15">
+  <p:cSld name="Slide 16">
     <p:bg>
       <p:bgPr>
         <a:solidFill>
@@ -9163,7 +10125,7 @@
                 <a:ea typeface="Trebuchet MS" pitchFamily="34" charset="-122"/>
                 <a:cs typeface="Trebuchet MS" pitchFamily="34" charset="-120"/>
               </a:rPr>
-              <a:t>15</a:t>
+              <a:t>16</a:t>
             </a:r>
             <a:endParaRPr lang="en-US" sz="1600" dirty="0"/>
           </a:p>
@@ -9242,7 +10204,7 @@
                 <a:ea typeface="Trebuchet MS" pitchFamily="34" charset="-122"/>
                 <a:cs typeface="Trebuchet MS" pitchFamily="34" charset="-120"/>
               </a:rPr>
-              <a:t>38</a:t>
+              <a:t>47</a:t>
             </a:r>
             <a:endParaRPr lang="en-US" sz="5200" dirty="0"/>
           </a:p>
@@ -9478,7 +10440,7 @@
                 <a:ea typeface="Trebuchet MS" pitchFamily="34" charset="-122"/>
                 <a:cs typeface="Trebuchet MS" pitchFamily="34" charset="-120"/>
               </a:rPr>
-              <a:t>13</a:t>
+              <a:t>20</a:t>
             </a:r>
             <a:endParaRPr lang="en-US" sz="5200" dirty="0"/>
           </a:p>
@@ -9596,7 +10558,7 @@
                 <a:ea typeface="Trebuchet MS" pitchFamily="34" charset="-122"/>
                 <a:cs typeface="Trebuchet MS" pitchFamily="34" charset="-120"/>
               </a:rPr>
-              <a:t>1</a:t>
+              <a:t>2</a:t>
             </a:r>
             <a:endParaRPr lang="en-US" sz="5200" dirty="0"/>
           </a:p>
@@ -9635,7 +10597,7 @@
                 <a:ea typeface="Calibri" pitchFamily="34" charset="-122"/>
                 <a:cs typeface="Calibri" pitchFamily="34" charset="-120"/>
               </a:rPr>
-              <a:t>conflicto resuelto</a:t>
+              <a:t>conflictos resueltos</a:t>
             </a:r>
             <a:endParaRPr lang="en-US" sz="1250" dirty="0"/>
           </a:p>
@@ -9871,7 +10833,7 @@
                 <a:ea typeface="Calibri" pitchFamily="34" charset="-122"/>
                 <a:cs typeface="Calibri" pitchFamily="34" charset="-120"/>
               </a:rPr>
-              <a:t>personas con commits</a:t>
+              <a:t>cuentas con commits</a:t>
             </a:r>
             <a:endParaRPr lang="en-US" sz="1250" dirty="0"/>
           </a:p>
@@ -9924,9 +10886,9 @@
 </p:sld>
 </file>
 
-<file path=ppt/slides/slide16.xml><?xml version="1.0" encoding="utf-8"?>
+<file path=ppt/slides/slide17.xml><?xml version="1.0" encoding="utf-8"?>
 <p:sld xmlns:a="http://schemas.openxmlformats.org/drawingml/2006/main" xmlns:r="http://schemas.openxmlformats.org/officeDocument/2006/relationships" xmlns:p="http://schemas.openxmlformats.org/presentationml/2006/main">
-  <p:cSld name="Slide 16">
+  <p:cSld name="Slide 17">
     <p:bg>
       <p:bgPr>
         <a:solidFill>
@@ -10079,7 +11041,7 @@
                 <a:ea typeface="Trebuchet MS" pitchFamily="34" charset="-122"/>
                 <a:cs typeface="Trebuchet MS" pitchFamily="34" charset="-120"/>
               </a:rPr>
-              <a:t>16</a:t>
+              <a:t>17</a:t>
             </a:r>
             <a:endParaRPr lang="en-US" sz="1600" dirty="0"/>
           </a:p>
@@ -11194,9 +12156,9 @@
 </p:sld>
 </file>
 
-<file path=ppt/slides/slide17.xml><?xml version="1.0" encoding="utf-8"?>
+<file path=ppt/slides/slide18.xml><?xml version="1.0" encoding="utf-8"?>
 <p:sld xmlns:a="http://schemas.openxmlformats.org/drawingml/2006/main" xmlns:r="http://schemas.openxmlformats.org/officeDocument/2006/relationships" xmlns:p="http://schemas.openxmlformats.org/presentationml/2006/main">
-  <p:cSld name="Slide 17">
+  <p:cSld name="Slide 18">
     <p:bg>
       <p:bgPr>
         <a:solidFill>
@@ -11485,7 +12447,7 @@
                 <a:ea typeface="Trebuchet MS" pitchFamily="34" charset="-122"/>
                 <a:cs typeface="Trebuchet MS" pitchFamily="34" charset="-120"/>
               </a:rPr>
-              <a:t>38</a:t>
+              <a:t>47</a:t>
             </a:r>
             <a:endParaRPr lang="en-US" sz="3000" dirty="0"/>
           </a:p>
@@ -11760,7 +12722,7 @@
                 <a:ea typeface="Calibri" pitchFamily="34" charset="-122"/>
                 <a:cs typeface="Calibri" pitchFamily="34" charset="-120"/>
               </a:rPr>
-              <a:t>releases</a:t>
+              <a:t>conflictos</a:t>
             </a:r>
             <a:endParaRPr lang="en-US" sz="1150" dirty="0"/>
           </a:p>
@@ -11839,7 +12801,7 @@
                 <a:ea typeface="Trebuchet MS" pitchFamily="34" charset="-122"/>
                 <a:cs typeface="Trebuchet MS" pitchFamily="34" charset="-120"/>
               </a:rPr>
-              <a:t>5</a:t>
+              <a:t>2</a:t>
             </a:r>
             <a:endParaRPr lang="en-US" sz="3000" dirty="0"/>
           </a:p>
@@ -11878,7 +12840,7 @@
                 <a:ea typeface="Calibri" pitchFamily="34" charset="-122"/>
                 <a:cs typeface="Calibri" pitchFamily="34" charset="-120"/>
               </a:rPr>
-              <a:t>autores</a:t>
+              <a:t>releases</a:t>
             </a:r>
             <a:endParaRPr lang="en-US" sz="1150" dirty="0"/>
           </a:p>
@@ -16503,12 +17465,80 @@
             <a:tbl>
               <a:tblPr/>
               <a:tblGrid>
-                <a:gridCol w="2468880"/>
+                <a:gridCol w="3840480"/>
+                <a:gridCol w="2286000"/>
                 <a:gridCol w="3291840"/>
-                <a:gridCol w="3657600"/>
                 <a:gridCol w="1463040"/>
               </a:tblGrid>
               <a:tr h="420624">
+                <a:tc>
+                  <a:txBody>
+                    <a:bodyPr/>
+                    <a:lstStyle/>
+                    <a:p>
+                      <a:pPr algn="l" indent="0" marL="0">
+                        <a:buNone/>
+                      </a:pPr>
+                      <a:r>
+                        <a:rPr lang="en-US" sz="1200" b="1" dirty="0">
+                          <a:solidFill>
+                            <a:srgbClr val="FFFFFF"/>
+                          </a:solidFill>
+                          <a:latin typeface="Calibri" pitchFamily="34" charset="0"/>
+                          <a:ea typeface="Calibri" pitchFamily="34" charset="-122"/>
+                          <a:cs typeface="Calibri" pitchFamily="34" charset="-120"/>
+                        </a:rPr>
+                        <a:t>Integrante</a:t>
+                      </a:r>
+                      <a:endParaRPr lang="en-US" sz="1200" dirty="0">
+                        <a:latin typeface="Calibri" charset="0"/>
+                        <a:ea typeface="Calibri" charset="0"/>
+                        <a:cs typeface="Calibri" charset="0"/>
+                      </a:endParaRPr>
+                    </a:p>
+                  </a:txBody>
+                  <a:tcPr marL="73152" marR="73152" marT="73152" marB="73152" anchor="ctr">
+                    <a:lnL w="12700" cap="flat" cmpd="sng" algn="ctr">
+                      <a:solidFill>
+                        <a:srgbClr val="D7DEE8"/>
+                      </a:solidFill>
+                      <a:prstDash val="solid"/>
+                      <a:round/>
+                      <a:headEnd type="none" w="med" len="med"/>
+                      <a:tailEnd type="none" w="med" len="med"/>
+                    </a:lnL>
+                    <a:lnR w="12700" cap="flat" cmpd="sng" algn="ctr">
+                      <a:solidFill>
+                        <a:srgbClr val="D7DEE8"/>
+                      </a:solidFill>
+                      <a:prstDash val="solid"/>
+                      <a:round/>
+                      <a:headEnd type="none" w="med" len="med"/>
+                      <a:tailEnd type="none" w="med" len="med"/>
+                    </a:lnR>
+                    <a:lnT w="12700" cap="flat" cmpd="sng" algn="ctr">
+                      <a:solidFill>
+                        <a:srgbClr val="D7DEE8"/>
+                      </a:solidFill>
+                      <a:prstDash val="solid"/>
+                      <a:round/>
+                      <a:headEnd type="none" w="med" len="med"/>
+                      <a:tailEnd type="none" w="med" len="med"/>
+                    </a:lnT>
+                    <a:lnB w="12700" cap="flat" cmpd="sng" algn="ctr">
+                      <a:solidFill>
+                        <a:srgbClr val="D7DEE8"/>
+                      </a:solidFill>
+                      <a:prstDash val="solid"/>
+                      <a:round/>
+                      <a:headEnd type="none" w="med" len="med"/>
+                      <a:tailEnd type="none" w="med" len="med"/>
+                    </a:lnB>
+                    <a:solidFill>
+                      <a:srgbClr val="0B1B2B"/>
+                    </a:solidFill>
+                  </a:tcPr>
+                </a:tc>
                 <a:tc>
                   <a:txBody>
                     <a:bodyPr/>
@@ -16650,74 +17680,6 @@
                     <a:bodyPr/>
                     <a:lstStyle/>
                     <a:p>
-                      <a:pPr algn="l" indent="0" marL="0">
-                        <a:buNone/>
-                      </a:pPr>
-                      <a:r>
-                        <a:rPr lang="en-US" sz="1200" b="1" dirty="0">
-                          <a:solidFill>
-                            <a:srgbClr val="FFFFFF"/>
-                          </a:solidFill>
-                          <a:latin typeface="Calibri" pitchFamily="34" charset="0"/>
-                          <a:ea typeface="Calibri" pitchFamily="34" charset="-122"/>
-                          <a:cs typeface="Calibri" pitchFamily="34" charset="-120"/>
-                        </a:rPr>
-                        <a:t>Rama de trabajo</a:t>
-                      </a:r>
-                      <a:endParaRPr lang="en-US" sz="1200" dirty="0">
-                        <a:latin typeface="Calibri" charset="0"/>
-                        <a:ea typeface="Calibri" charset="0"/>
-                        <a:cs typeface="Calibri" charset="0"/>
-                      </a:endParaRPr>
-                    </a:p>
-                  </a:txBody>
-                  <a:tcPr marL="73152" marR="73152" marT="73152" marB="73152" anchor="ctr">
-                    <a:lnL w="12700" cap="flat" cmpd="sng" algn="ctr">
-                      <a:solidFill>
-                        <a:srgbClr val="D7DEE8"/>
-                      </a:solidFill>
-                      <a:prstDash val="solid"/>
-                      <a:round/>
-                      <a:headEnd type="none" w="med" len="med"/>
-                      <a:tailEnd type="none" w="med" len="med"/>
-                    </a:lnL>
-                    <a:lnR w="12700" cap="flat" cmpd="sng" algn="ctr">
-                      <a:solidFill>
-                        <a:srgbClr val="D7DEE8"/>
-                      </a:solidFill>
-                      <a:prstDash val="solid"/>
-                      <a:round/>
-                      <a:headEnd type="none" w="med" len="med"/>
-                      <a:tailEnd type="none" w="med" len="med"/>
-                    </a:lnR>
-                    <a:lnT w="12700" cap="flat" cmpd="sng" algn="ctr">
-                      <a:solidFill>
-                        <a:srgbClr val="D7DEE8"/>
-                      </a:solidFill>
-                      <a:prstDash val="solid"/>
-                      <a:round/>
-                      <a:headEnd type="none" w="med" len="med"/>
-                      <a:tailEnd type="none" w="med" len="med"/>
-                    </a:lnT>
-                    <a:lnB w="12700" cap="flat" cmpd="sng" algn="ctr">
-                      <a:solidFill>
-                        <a:srgbClr val="D7DEE8"/>
-                      </a:solidFill>
-                      <a:prstDash val="solid"/>
-                      <a:round/>
-                      <a:headEnd type="none" w="med" len="med"/>
-                      <a:tailEnd type="none" w="med" len="med"/>
-                    </a:lnB>
-                    <a:solidFill>
-                      <a:srgbClr val="0B1B2B"/>
-                    </a:solidFill>
-                  </a:tcPr>
-                </a:tc>
-                <a:tc>
-                  <a:txBody>
-                    <a:bodyPr/>
-                    <a:lstStyle/>
-                    <a:p>
                       <a:pPr algn="ctr" indent="0" marL="0">
                         <a:buNone/>
                       </a:pPr>
@@ -16783,6 +17745,74 @@
                 </a:tc>
               </a:tr>
               <a:tr h="420624">
+                <a:tc>
+                  <a:txBody>
+                    <a:bodyPr/>
+                    <a:lstStyle/>
+                    <a:p>
+                      <a:pPr indent="0" marL="0">
+                        <a:buNone/>
+                      </a:pPr>
+                      <a:r>
+                        <a:rPr lang="en-US" sz="1200" dirty="0">
+                          <a:solidFill>
+                            <a:srgbClr val="0F172A"/>
+                          </a:solidFill>
+                          <a:latin typeface="Calibri" pitchFamily="34" charset="0"/>
+                          <a:ea typeface="Calibri" pitchFamily="34" charset="-122"/>
+                          <a:cs typeface="Calibri" pitchFamily="34" charset="-120"/>
+                        </a:rPr>
+                        <a:t>Barrueta Quispe, Yeferson</a:t>
+                      </a:r>
+                      <a:endParaRPr lang="en-US" sz="1200" dirty="0">
+                        <a:latin typeface="Calibri" charset="0"/>
+                        <a:ea typeface="Calibri" charset="0"/>
+                        <a:cs typeface="Calibri" charset="0"/>
+                      </a:endParaRPr>
+                    </a:p>
+                  </a:txBody>
+                  <a:tcPr marL="73152" marR="73152" marT="73152" marB="73152" anchor="ctr">
+                    <a:lnL w="12700" cap="flat" cmpd="sng" algn="ctr">
+                      <a:solidFill>
+                        <a:srgbClr val="D7DEE8"/>
+                      </a:solidFill>
+                      <a:prstDash val="solid"/>
+                      <a:round/>
+                      <a:headEnd type="none" w="med" len="med"/>
+                      <a:tailEnd type="none" w="med" len="med"/>
+                    </a:lnL>
+                    <a:lnR w="12700" cap="flat" cmpd="sng" algn="ctr">
+                      <a:solidFill>
+                        <a:srgbClr val="D7DEE8"/>
+                      </a:solidFill>
+                      <a:prstDash val="solid"/>
+                      <a:round/>
+                      <a:headEnd type="none" w="med" len="med"/>
+                      <a:tailEnd type="none" w="med" len="med"/>
+                    </a:lnR>
+                    <a:lnT w="12700" cap="flat" cmpd="sng" algn="ctr">
+                      <a:solidFill>
+                        <a:srgbClr val="D7DEE8"/>
+                      </a:solidFill>
+                      <a:prstDash val="solid"/>
+                      <a:round/>
+                      <a:headEnd type="none" w="med" len="med"/>
+                      <a:tailEnd type="none" w="med" len="med"/>
+                    </a:lnT>
+                    <a:lnB w="12700" cap="flat" cmpd="sng" algn="ctr">
+                      <a:solidFill>
+                        <a:srgbClr val="D7DEE8"/>
+                      </a:solidFill>
+                      <a:prstDash val="solid"/>
+                      <a:round/>
+                      <a:headEnd type="none" w="med" len="med"/>
+                      <a:tailEnd type="none" w="med" len="med"/>
+                    </a:lnB>
+                    <a:solidFill>
+                      <a:srgbClr val="FFFFFF"/>
+                    </a:solidFill>
+                  </a:tcPr>
+                </a:tc>
                 <a:tc>
                   <a:txBody>
                     <a:bodyPr/>
@@ -16924,74 +17954,6 @@
                     <a:bodyPr/>
                     <a:lstStyle/>
                     <a:p>
-                      <a:pPr indent="0" marL="0">
-                        <a:buNone/>
-                      </a:pPr>
-                      <a:r>
-                        <a:rPr lang="en-US" sz="1200" dirty="0">
-                          <a:solidFill>
-                            <a:srgbClr val="0F172A"/>
-                          </a:solidFill>
-                          <a:latin typeface="Calibri" pitchFamily="34" charset="0"/>
-                          <a:ea typeface="Calibri" pitchFamily="34" charset="-122"/>
-                          <a:cs typeface="Calibri" pitchFamily="34" charset="-120"/>
-                        </a:rPr>
-                        <a:t>feature/catalogo-libros</a:t>
-                      </a:r>
-                      <a:endParaRPr lang="en-US" sz="1200" dirty="0">
-                        <a:latin typeface="Calibri" charset="0"/>
-                        <a:ea typeface="Calibri" charset="0"/>
-                        <a:cs typeface="Calibri" charset="0"/>
-                      </a:endParaRPr>
-                    </a:p>
-                  </a:txBody>
-                  <a:tcPr marL="73152" marR="73152" marT="73152" marB="73152" anchor="ctr">
-                    <a:lnL w="12700" cap="flat" cmpd="sng" algn="ctr">
-                      <a:solidFill>
-                        <a:srgbClr val="D7DEE8"/>
-                      </a:solidFill>
-                      <a:prstDash val="solid"/>
-                      <a:round/>
-                      <a:headEnd type="none" w="med" len="med"/>
-                      <a:tailEnd type="none" w="med" len="med"/>
-                    </a:lnL>
-                    <a:lnR w="12700" cap="flat" cmpd="sng" algn="ctr">
-                      <a:solidFill>
-                        <a:srgbClr val="D7DEE8"/>
-                      </a:solidFill>
-                      <a:prstDash val="solid"/>
-                      <a:round/>
-                      <a:headEnd type="none" w="med" len="med"/>
-                      <a:tailEnd type="none" w="med" len="med"/>
-                    </a:lnR>
-                    <a:lnT w="12700" cap="flat" cmpd="sng" algn="ctr">
-                      <a:solidFill>
-                        <a:srgbClr val="D7DEE8"/>
-                      </a:solidFill>
-                      <a:prstDash val="solid"/>
-                      <a:round/>
-                      <a:headEnd type="none" w="med" len="med"/>
-                      <a:tailEnd type="none" w="med" len="med"/>
-                    </a:lnT>
-                    <a:lnB w="12700" cap="flat" cmpd="sng" algn="ctr">
-                      <a:solidFill>
-                        <a:srgbClr val="D7DEE8"/>
-                      </a:solidFill>
-                      <a:prstDash val="solid"/>
-                      <a:round/>
-                      <a:headEnd type="none" w="med" len="med"/>
-                      <a:tailEnd type="none" w="med" len="med"/>
-                    </a:lnB>
-                    <a:solidFill>
-                      <a:srgbClr val="FFFFFF"/>
-                    </a:solidFill>
-                  </a:tcPr>
-                </a:tc>
-                <a:tc>
-                  <a:txBody>
-                    <a:bodyPr/>
-                    <a:lstStyle/>
-                    <a:p>
                       <a:pPr algn="ctr" indent="0" marL="0">
                         <a:buNone/>
                       </a:pPr>
@@ -17057,6 +18019,74 @@
                 </a:tc>
               </a:tr>
               <a:tr h="420624">
+                <a:tc>
+                  <a:txBody>
+                    <a:bodyPr/>
+                    <a:lstStyle/>
+                    <a:p>
+                      <a:pPr indent="0" marL="0">
+                        <a:buNone/>
+                      </a:pPr>
+                      <a:r>
+                        <a:rPr lang="en-US" sz="1200" dirty="0">
+                          <a:solidFill>
+                            <a:srgbClr val="0F172A"/>
+                          </a:solidFill>
+                          <a:latin typeface="Calibri" pitchFamily="34" charset="0"/>
+                          <a:ea typeface="Calibri" pitchFamily="34" charset="-122"/>
+                          <a:cs typeface="Calibri" pitchFamily="34" charset="-120"/>
+                        </a:rPr>
+                        <a:t>Antonio Loayza, Cristian Yharen</a:t>
+                      </a:r>
+                      <a:endParaRPr lang="en-US" sz="1200" dirty="0">
+                        <a:latin typeface="Calibri" charset="0"/>
+                        <a:ea typeface="Calibri" charset="0"/>
+                        <a:cs typeface="Calibri" charset="0"/>
+                      </a:endParaRPr>
+                    </a:p>
+                  </a:txBody>
+                  <a:tcPr marL="73152" marR="73152" marT="73152" marB="73152" anchor="ctr">
+                    <a:lnL w="12700" cap="flat" cmpd="sng" algn="ctr">
+                      <a:solidFill>
+                        <a:srgbClr val="D7DEE8"/>
+                      </a:solidFill>
+                      <a:prstDash val="solid"/>
+                      <a:round/>
+                      <a:headEnd type="none" w="med" len="med"/>
+                      <a:tailEnd type="none" w="med" len="med"/>
+                    </a:lnL>
+                    <a:lnR w="12700" cap="flat" cmpd="sng" algn="ctr">
+                      <a:solidFill>
+                        <a:srgbClr val="D7DEE8"/>
+                      </a:solidFill>
+                      <a:prstDash val="solid"/>
+                      <a:round/>
+                      <a:headEnd type="none" w="med" len="med"/>
+                      <a:tailEnd type="none" w="med" len="med"/>
+                    </a:lnR>
+                    <a:lnT w="12700" cap="flat" cmpd="sng" algn="ctr">
+                      <a:solidFill>
+                        <a:srgbClr val="D7DEE8"/>
+                      </a:solidFill>
+                      <a:prstDash val="solid"/>
+                      <a:round/>
+                      <a:headEnd type="none" w="med" len="med"/>
+                      <a:tailEnd type="none" w="med" len="med"/>
+                    </a:lnT>
+                    <a:lnB w="12700" cap="flat" cmpd="sng" algn="ctr">
+                      <a:solidFill>
+                        <a:srgbClr val="D7DEE8"/>
+                      </a:solidFill>
+                      <a:prstDash val="solid"/>
+                      <a:round/>
+                      <a:headEnd type="none" w="med" len="med"/>
+                      <a:tailEnd type="none" w="med" len="med"/>
+                    </a:lnB>
+                    <a:solidFill>
+                      <a:srgbClr val="FFFFFF"/>
+                    </a:solidFill>
+                  </a:tcPr>
+                </a:tc>
                 <a:tc>
                   <a:txBody>
                     <a:bodyPr/>
@@ -17198,74 +18228,6 @@
                     <a:bodyPr/>
                     <a:lstStyle/>
                     <a:p>
-                      <a:pPr indent="0" marL="0">
-                        <a:buNone/>
-                      </a:pPr>
-                      <a:r>
-                        <a:rPr lang="en-US" sz="1200" dirty="0">
-                          <a:solidFill>
-                            <a:srgbClr val="0F172A"/>
-                          </a:solidFill>
-                          <a:latin typeface="Calibri" pitchFamily="34" charset="0"/>
-                          <a:ea typeface="Calibri" pitchFamily="34" charset="-122"/>
-                          <a:cs typeface="Calibri" pitchFamily="34" charset="-120"/>
-                        </a:rPr>
-                        <a:t>feature/gestion-socios</a:t>
-                      </a:r>
-                      <a:endParaRPr lang="en-US" sz="1200" dirty="0">
-                        <a:latin typeface="Calibri" charset="0"/>
-                        <a:ea typeface="Calibri" charset="0"/>
-                        <a:cs typeface="Calibri" charset="0"/>
-                      </a:endParaRPr>
-                    </a:p>
-                  </a:txBody>
-                  <a:tcPr marL="73152" marR="73152" marT="73152" marB="73152" anchor="ctr">
-                    <a:lnL w="12700" cap="flat" cmpd="sng" algn="ctr">
-                      <a:solidFill>
-                        <a:srgbClr val="D7DEE8"/>
-                      </a:solidFill>
-                      <a:prstDash val="solid"/>
-                      <a:round/>
-                      <a:headEnd type="none" w="med" len="med"/>
-                      <a:tailEnd type="none" w="med" len="med"/>
-                    </a:lnL>
-                    <a:lnR w="12700" cap="flat" cmpd="sng" algn="ctr">
-                      <a:solidFill>
-                        <a:srgbClr val="D7DEE8"/>
-                      </a:solidFill>
-                      <a:prstDash val="solid"/>
-                      <a:round/>
-                      <a:headEnd type="none" w="med" len="med"/>
-                      <a:tailEnd type="none" w="med" len="med"/>
-                    </a:lnR>
-                    <a:lnT w="12700" cap="flat" cmpd="sng" algn="ctr">
-                      <a:solidFill>
-                        <a:srgbClr val="D7DEE8"/>
-                      </a:solidFill>
-                      <a:prstDash val="solid"/>
-                      <a:round/>
-                      <a:headEnd type="none" w="med" len="med"/>
-                      <a:tailEnd type="none" w="med" len="med"/>
-                    </a:lnT>
-                    <a:lnB w="12700" cap="flat" cmpd="sng" algn="ctr">
-                      <a:solidFill>
-                        <a:srgbClr val="D7DEE8"/>
-                      </a:solidFill>
-                      <a:prstDash val="solid"/>
-                      <a:round/>
-                      <a:headEnd type="none" w="med" len="med"/>
-                      <a:tailEnd type="none" w="med" len="med"/>
-                    </a:lnB>
-                    <a:solidFill>
-                      <a:srgbClr val="FFFFFF"/>
-                    </a:solidFill>
-                  </a:tcPr>
-                </a:tc>
-                <a:tc>
-                  <a:txBody>
-                    <a:bodyPr/>
-                    <a:lstStyle/>
-                    <a:p>
                       <a:pPr algn="ctr" indent="0" marL="0">
                         <a:buNone/>
                       </a:pPr>
@@ -17278,7 +18240,7 @@
                           <a:ea typeface="Calibri" pitchFamily="34" charset="-122"/>
                           <a:cs typeface="Calibri" pitchFamily="34" charset="-120"/>
                         </a:rPr>
-                        <a:t>6</a:t>
+                        <a:t>7</a:t>
                       </a:r>
                       <a:endParaRPr lang="en-US" sz="1200" dirty="0">
                         <a:latin typeface="Calibri" charset="0"/>
@@ -17331,6 +18293,74 @@
                 </a:tc>
               </a:tr>
               <a:tr h="420624">
+                <a:tc>
+                  <a:txBody>
+                    <a:bodyPr/>
+                    <a:lstStyle/>
+                    <a:p>
+                      <a:pPr indent="0" marL="0">
+                        <a:buNone/>
+                      </a:pPr>
+                      <a:r>
+                        <a:rPr lang="en-US" sz="1200" dirty="0">
+                          <a:solidFill>
+                            <a:srgbClr val="0F172A"/>
+                          </a:solidFill>
+                          <a:latin typeface="Calibri" pitchFamily="34" charset="0"/>
+                          <a:ea typeface="Calibri" pitchFamily="34" charset="-122"/>
+                          <a:cs typeface="Calibri" pitchFamily="34" charset="-120"/>
+                        </a:rPr>
+                        <a:t>Huillca Loco, Andre</a:t>
+                      </a:r>
+                      <a:endParaRPr lang="en-US" sz="1200" dirty="0">
+                        <a:latin typeface="Calibri" charset="0"/>
+                        <a:ea typeface="Calibri" charset="0"/>
+                        <a:cs typeface="Calibri" charset="0"/>
+                      </a:endParaRPr>
+                    </a:p>
+                  </a:txBody>
+                  <a:tcPr marL="73152" marR="73152" marT="73152" marB="73152" anchor="ctr">
+                    <a:lnL w="12700" cap="flat" cmpd="sng" algn="ctr">
+                      <a:solidFill>
+                        <a:srgbClr val="D7DEE8"/>
+                      </a:solidFill>
+                      <a:prstDash val="solid"/>
+                      <a:round/>
+                      <a:headEnd type="none" w="med" len="med"/>
+                      <a:tailEnd type="none" w="med" len="med"/>
+                    </a:lnL>
+                    <a:lnR w="12700" cap="flat" cmpd="sng" algn="ctr">
+                      <a:solidFill>
+                        <a:srgbClr val="D7DEE8"/>
+                      </a:solidFill>
+                      <a:prstDash val="solid"/>
+                      <a:round/>
+                      <a:headEnd type="none" w="med" len="med"/>
+                      <a:tailEnd type="none" w="med" len="med"/>
+                    </a:lnR>
+                    <a:lnT w="12700" cap="flat" cmpd="sng" algn="ctr">
+                      <a:solidFill>
+                        <a:srgbClr val="D7DEE8"/>
+                      </a:solidFill>
+                      <a:prstDash val="solid"/>
+                      <a:round/>
+                      <a:headEnd type="none" w="med" len="med"/>
+                      <a:tailEnd type="none" w="med" len="med"/>
+                    </a:lnT>
+                    <a:lnB w="12700" cap="flat" cmpd="sng" algn="ctr">
+                      <a:solidFill>
+                        <a:srgbClr val="D7DEE8"/>
+                      </a:solidFill>
+                      <a:prstDash val="solid"/>
+                      <a:round/>
+                      <a:headEnd type="none" w="med" len="med"/>
+                      <a:tailEnd type="none" w="med" len="med"/>
+                    </a:lnB>
+                    <a:solidFill>
+                      <a:srgbClr val="FFFFFF"/>
+                    </a:solidFill>
+                  </a:tcPr>
+                </a:tc>
                 <a:tc>
                   <a:txBody>
                     <a:bodyPr/>
@@ -17472,74 +18502,6 @@
                     <a:bodyPr/>
                     <a:lstStyle/>
                     <a:p>
-                      <a:pPr indent="0" marL="0">
-                        <a:buNone/>
-                      </a:pPr>
-                      <a:r>
-                        <a:rPr lang="en-US" sz="1200" dirty="0">
-                          <a:solidFill>
-                            <a:srgbClr val="0F172A"/>
-                          </a:solidFill>
-                          <a:latin typeface="Calibri" pitchFamily="34" charset="0"/>
-                          <a:ea typeface="Calibri" pitchFamily="34" charset="-122"/>
-                          <a:cs typeface="Calibri" pitchFamily="34" charset="-120"/>
-                        </a:rPr>
-                        <a:t>feature/prestamos</a:t>
-                      </a:r>
-                      <a:endParaRPr lang="en-US" sz="1200" dirty="0">
-                        <a:latin typeface="Calibri" charset="0"/>
-                        <a:ea typeface="Calibri" charset="0"/>
-                        <a:cs typeface="Calibri" charset="0"/>
-                      </a:endParaRPr>
-                    </a:p>
-                  </a:txBody>
-                  <a:tcPr marL="73152" marR="73152" marT="73152" marB="73152" anchor="ctr">
-                    <a:lnL w="12700" cap="flat" cmpd="sng" algn="ctr">
-                      <a:solidFill>
-                        <a:srgbClr val="D7DEE8"/>
-                      </a:solidFill>
-                      <a:prstDash val="solid"/>
-                      <a:round/>
-                      <a:headEnd type="none" w="med" len="med"/>
-                      <a:tailEnd type="none" w="med" len="med"/>
-                    </a:lnL>
-                    <a:lnR w="12700" cap="flat" cmpd="sng" algn="ctr">
-                      <a:solidFill>
-                        <a:srgbClr val="D7DEE8"/>
-                      </a:solidFill>
-                      <a:prstDash val="solid"/>
-                      <a:round/>
-                      <a:headEnd type="none" w="med" len="med"/>
-                      <a:tailEnd type="none" w="med" len="med"/>
-                    </a:lnR>
-                    <a:lnT w="12700" cap="flat" cmpd="sng" algn="ctr">
-                      <a:solidFill>
-                        <a:srgbClr val="D7DEE8"/>
-                      </a:solidFill>
-                      <a:prstDash val="solid"/>
-                      <a:round/>
-                      <a:headEnd type="none" w="med" len="med"/>
-                      <a:tailEnd type="none" w="med" len="med"/>
-                    </a:lnT>
-                    <a:lnB w="12700" cap="flat" cmpd="sng" algn="ctr">
-                      <a:solidFill>
-                        <a:srgbClr val="D7DEE8"/>
-                      </a:solidFill>
-                      <a:prstDash val="solid"/>
-                      <a:round/>
-                      <a:headEnd type="none" w="med" len="med"/>
-                      <a:tailEnd type="none" w="med" len="med"/>
-                    </a:lnB>
-                    <a:solidFill>
-                      <a:srgbClr val="FFFFFF"/>
-                    </a:solidFill>
-                  </a:tcPr>
-                </a:tc>
-                <a:tc>
-                  <a:txBody>
-                    <a:bodyPr/>
-                    <a:lstStyle/>
-                    <a:p>
                       <a:pPr algn="ctr" indent="0" marL="0">
                         <a:buNone/>
                       </a:pPr>
@@ -17552,7 +18514,7 @@
                           <a:ea typeface="Calibri" pitchFamily="34" charset="-122"/>
                           <a:cs typeface="Calibri" pitchFamily="34" charset="-120"/>
                         </a:rPr>
-                        <a:t>5</a:t>
+                        <a:t>6</a:t>
                       </a:r>
                       <a:endParaRPr lang="en-US" sz="1200" dirty="0">
                         <a:latin typeface="Calibri" charset="0"/>
@@ -17605,6 +18567,74 @@
                 </a:tc>
               </a:tr>
               <a:tr h="420624">
+                <a:tc>
+                  <a:txBody>
+                    <a:bodyPr/>
+                    <a:lstStyle/>
+                    <a:p>
+                      <a:pPr indent="0" marL="0">
+                        <a:buNone/>
+                      </a:pPr>
+                      <a:r>
+                        <a:rPr lang="en-US" sz="1200" dirty="0">
+                          <a:solidFill>
+                            <a:srgbClr val="0F172A"/>
+                          </a:solidFill>
+                          <a:latin typeface="Calibri" pitchFamily="34" charset="0"/>
+                          <a:ea typeface="Calibri" pitchFamily="34" charset="-122"/>
+                          <a:cs typeface="Calibri" pitchFamily="34" charset="-120"/>
+                        </a:rPr>
+                        <a:t>Gonzales del Valle Vargas, Marco Antonio</a:t>
+                      </a:r>
+                      <a:endParaRPr lang="en-US" sz="1200" dirty="0">
+                        <a:latin typeface="Calibri" charset="0"/>
+                        <a:ea typeface="Calibri" charset="0"/>
+                        <a:cs typeface="Calibri" charset="0"/>
+                      </a:endParaRPr>
+                    </a:p>
+                  </a:txBody>
+                  <a:tcPr marL="73152" marR="73152" marT="73152" marB="73152" anchor="ctr">
+                    <a:lnL w="12700" cap="flat" cmpd="sng" algn="ctr">
+                      <a:solidFill>
+                        <a:srgbClr val="D7DEE8"/>
+                      </a:solidFill>
+                      <a:prstDash val="solid"/>
+                      <a:round/>
+                      <a:headEnd type="none" w="med" len="med"/>
+                      <a:tailEnd type="none" w="med" len="med"/>
+                    </a:lnL>
+                    <a:lnR w="12700" cap="flat" cmpd="sng" algn="ctr">
+                      <a:solidFill>
+                        <a:srgbClr val="D7DEE8"/>
+                      </a:solidFill>
+                      <a:prstDash val="solid"/>
+                      <a:round/>
+                      <a:headEnd type="none" w="med" len="med"/>
+                      <a:tailEnd type="none" w="med" len="med"/>
+                    </a:lnR>
+                    <a:lnT w="12700" cap="flat" cmpd="sng" algn="ctr">
+                      <a:solidFill>
+                        <a:srgbClr val="D7DEE8"/>
+                      </a:solidFill>
+                      <a:prstDash val="solid"/>
+                      <a:round/>
+                      <a:headEnd type="none" w="med" len="med"/>
+                      <a:tailEnd type="none" w="med" len="med"/>
+                    </a:lnT>
+                    <a:lnB w="12700" cap="flat" cmpd="sng" algn="ctr">
+                      <a:solidFill>
+                        <a:srgbClr val="D7DEE8"/>
+                      </a:solidFill>
+                      <a:prstDash val="solid"/>
+                      <a:round/>
+                      <a:headEnd type="none" w="med" len="med"/>
+                      <a:tailEnd type="none" w="med" len="med"/>
+                    </a:lnB>
+                    <a:solidFill>
+                      <a:srgbClr val="FFFFFF"/>
+                    </a:solidFill>
+                  </a:tcPr>
+                </a:tc>
                 <a:tc>
                   <a:txBody>
                     <a:bodyPr/>
@@ -17746,74 +18776,6 @@
                     <a:bodyPr/>
                     <a:lstStyle/>
                     <a:p>
-                      <a:pPr indent="0" marL="0">
-                        <a:buNone/>
-                      </a:pPr>
-                      <a:r>
-                        <a:rPr lang="en-US" sz="1200" dirty="0">
-                          <a:solidFill>
-                            <a:srgbClr val="0F172A"/>
-                          </a:solidFill>
-                          <a:latin typeface="Calibri" pitchFamily="34" charset="0"/>
-                          <a:ea typeface="Calibri" pitchFamily="34" charset="-122"/>
-                          <a:cs typeface="Calibri" pitchFamily="34" charset="-120"/>
-                        </a:rPr>
-                        <a:t>feature/reportes-dashboard</a:t>
-                      </a:r>
-                      <a:endParaRPr lang="en-US" sz="1200" dirty="0">
-                        <a:latin typeface="Calibri" charset="0"/>
-                        <a:ea typeface="Calibri" charset="0"/>
-                        <a:cs typeface="Calibri" charset="0"/>
-                      </a:endParaRPr>
-                    </a:p>
-                  </a:txBody>
-                  <a:tcPr marL="73152" marR="73152" marT="73152" marB="73152" anchor="ctr">
-                    <a:lnL w="12700" cap="flat" cmpd="sng" algn="ctr">
-                      <a:solidFill>
-                        <a:srgbClr val="D7DEE8"/>
-                      </a:solidFill>
-                      <a:prstDash val="solid"/>
-                      <a:round/>
-                      <a:headEnd type="none" w="med" len="med"/>
-                      <a:tailEnd type="none" w="med" len="med"/>
-                    </a:lnL>
-                    <a:lnR w="12700" cap="flat" cmpd="sng" algn="ctr">
-                      <a:solidFill>
-                        <a:srgbClr val="D7DEE8"/>
-                      </a:solidFill>
-                      <a:prstDash val="solid"/>
-                      <a:round/>
-                      <a:headEnd type="none" w="med" len="med"/>
-                      <a:tailEnd type="none" w="med" len="med"/>
-                    </a:lnR>
-                    <a:lnT w="12700" cap="flat" cmpd="sng" algn="ctr">
-                      <a:solidFill>
-                        <a:srgbClr val="D7DEE8"/>
-                      </a:solidFill>
-                      <a:prstDash val="solid"/>
-                      <a:round/>
-                      <a:headEnd type="none" w="med" len="med"/>
-                      <a:tailEnd type="none" w="med" len="med"/>
-                    </a:lnT>
-                    <a:lnB w="12700" cap="flat" cmpd="sng" algn="ctr">
-                      <a:solidFill>
-                        <a:srgbClr val="D7DEE8"/>
-                      </a:solidFill>
-                      <a:prstDash val="solid"/>
-                      <a:round/>
-                      <a:headEnd type="none" w="med" len="med"/>
-                      <a:tailEnd type="none" w="med" len="med"/>
-                    </a:lnB>
-                    <a:solidFill>
-                      <a:srgbClr val="FFFFFF"/>
-                    </a:solidFill>
-                  </a:tcPr>
-                </a:tc>
-                <a:tc>
-                  <a:txBody>
-                    <a:bodyPr/>
-                    <a:lstStyle/>
-                    <a:p>
                       <a:pPr algn="ctr" indent="0" marL="0">
                         <a:buNone/>
                       </a:pPr>
@@ -17826,7 +18788,7 @@
                           <a:ea typeface="Calibri" pitchFamily="34" charset="-122"/>
                           <a:cs typeface="Calibri" pitchFamily="34" charset="-120"/>
                         </a:rPr>
-                        <a:t>22</a:t>
+                        <a:t>29</a:t>
                       </a:r>
                       <a:endParaRPr lang="en-US" sz="1200" dirty="0">
                         <a:latin typeface="Calibri" charset="0"/>
@@ -17879,6 +18841,74 @@
                 </a:tc>
               </a:tr>
               <a:tr h="420624">
+                <a:tc>
+                  <a:txBody>
+                    <a:bodyPr/>
+                    <a:lstStyle/>
+                    <a:p>
+                      <a:pPr indent="0" marL="0">
+                        <a:buNone/>
+                      </a:pPr>
+                      <a:r>
+                        <a:rPr lang="en-US" sz="1200" b="1" dirty="0">
+                          <a:solidFill>
+                            <a:srgbClr val="1D4ED8"/>
+                          </a:solidFill>
+                          <a:latin typeface="Calibri" pitchFamily="34" charset="0"/>
+                          <a:ea typeface="Calibri" pitchFamily="34" charset="-122"/>
+                          <a:cs typeface="Calibri" pitchFamily="34" charset="-120"/>
+                        </a:rPr>
+                        <a:t>[Apellidos y nombres]</a:t>
+                      </a:r>
+                      <a:endParaRPr lang="en-US" sz="1200" dirty="0">
+                        <a:latin typeface="Calibri" charset="0"/>
+                        <a:ea typeface="Calibri" charset="0"/>
+                        <a:cs typeface="Calibri" charset="0"/>
+                      </a:endParaRPr>
+                    </a:p>
+                  </a:txBody>
+                  <a:tcPr marL="73152" marR="73152" marT="73152" marB="73152" anchor="ctr">
+                    <a:lnL w="12700" cap="flat" cmpd="sng" algn="ctr">
+                      <a:solidFill>
+                        <a:srgbClr val="D7DEE8"/>
+                      </a:solidFill>
+                      <a:prstDash val="solid"/>
+                      <a:round/>
+                      <a:headEnd type="none" w="med" len="med"/>
+                      <a:tailEnd type="none" w="med" len="med"/>
+                    </a:lnL>
+                    <a:lnR w="12700" cap="flat" cmpd="sng" algn="ctr">
+                      <a:solidFill>
+                        <a:srgbClr val="D7DEE8"/>
+                      </a:solidFill>
+                      <a:prstDash val="solid"/>
+                      <a:round/>
+                      <a:headEnd type="none" w="med" len="med"/>
+                      <a:tailEnd type="none" w="med" len="med"/>
+                    </a:lnR>
+                    <a:lnT w="12700" cap="flat" cmpd="sng" algn="ctr">
+                      <a:solidFill>
+                        <a:srgbClr val="D7DEE8"/>
+                      </a:solidFill>
+                      <a:prstDash val="solid"/>
+                      <a:round/>
+                      <a:headEnd type="none" w="med" len="med"/>
+                      <a:tailEnd type="none" w="med" len="med"/>
+                    </a:lnT>
+                    <a:lnB w="12700" cap="flat" cmpd="sng" algn="ctr">
+                      <a:solidFill>
+                        <a:srgbClr val="D7DEE8"/>
+                      </a:solidFill>
+                      <a:prstDash val="solid"/>
+                      <a:round/>
+                      <a:headEnd type="none" w="med" len="med"/>
+                      <a:tailEnd type="none" w="med" len="med"/>
+                    </a:lnB>
+                    <a:solidFill>
+                      <a:srgbClr val="FFFFFF"/>
+                    </a:solidFill>
+                  </a:tcPr>
+                </a:tc>
                 <a:tc>
                   <a:txBody>
                     <a:bodyPr/>
@@ -17965,74 +18995,6 @@
                           <a:cs typeface="Calibri" pitchFamily="34" charset="-120"/>
                         </a:rPr>
                         <a:t>Mejoras de UI/UX y Login</a:t>
-                      </a:r>
-                      <a:endParaRPr lang="en-US" sz="1200" dirty="0">
-                        <a:latin typeface="Calibri" charset="0"/>
-                        <a:ea typeface="Calibri" charset="0"/>
-                        <a:cs typeface="Calibri" charset="0"/>
-                      </a:endParaRPr>
-                    </a:p>
-                  </a:txBody>
-                  <a:tcPr marL="73152" marR="73152" marT="73152" marB="73152" anchor="ctr">
-                    <a:lnL w="12700" cap="flat" cmpd="sng" algn="ctr">
-                      <a:solidFill>
-                        <a:srgbClr val="D7DEE8"/>
-                      </a:solidFill>
-                      <a:prstDash val="solid"/>
-                      <a:round/>
-                      <a:headEnd type="none" w="med" len="med"/>
-                      <a:tailEnd type="none" w="med" len="med"/>
-                    </a:lnL>
-                    <a:lnR w="12700" cap="flat" cmpd="sng" algn="ctr">
-                      <a:solidFill>
-                        <a:srgbClr val="D7DEE8"/>
-                      </a:solidFill>
-                      <a:prstDash val="solid"/>
-                      <a:round/>
-                      <a:headEnd type="none" w="med" len="med"/>
-                      <a:tailEnd type="none" w="med" len="med"/>
-                    </a:lnR>
-                    <a:lnT w="12700" cap="flat" cmpd="sng" algn="ctr">
-                      <a:solidFill>
-                        <a:srgbClr val="D7DEE8"/>
-                      </a:solidFill>
-                      <a:prstDash val="solid"/>
-                      <a:round/>
-                      <a:headEnd type="none" w="med" len="med"/>
-                      <a:tailEnd type="none" w="med" len="med"/>
-                    </a:lnT>
-                    <a:lnB w="12700" cap="flat" cmpd="sng" algn="ctr">
-                      <a:solidFill>
-                        <a:srgbClr val="D7DEE8"/>
-                      </a:solidFill>
-                      <a:prstDash val="solid"/>
-                      <a:round/>
-                      <a:headEnd type="none" w="med" len="med"/>
-                      <a:tailEnd type="none" w="med" len="med"/>
-                    </a:lnB>
-                    <a:solidFill>
-                      <a:srgbClr val="FFFFFF"/>
-                    </a:solidFill>
-                  </a:tcPr>
-                </a:tc>
-                <a:tc>
-                  <a:txBody>
-                    <a:bodyPr/>
-                    <a:lstStyle/>
-                    <a:p>
-                      <a:pPr indent="0" marL="0">
-                        <a:buNone/>
-                      </a:pPr>
-                      <a:r>
-                        <a:rPr lang="en-US" sz="1200" dirty="0">
-                          <a:solidFill>
-                            <a:srgbClr val="0F172A"/>
-                          </a:solidFill>
-                          <a:latin typeface="Calibri" pitchFamily="34" charset="0"/>
-                          <a:ea typeface="Calibri" pitchFamily="34" charset="-122"/>
-                          <a:cs typeface="Calibri" pitchFamily="34" charset="-120"/>
-                        </a:rPr>
-                        <a:t>main (integración posterior)</a:t>
                       </a:r>
                       <a:endParaRPr lang="en-US" sz="1200" dirty="0">
                         <a:latin typeface="Calibri" charset="0"/>

</xml_diff>